<commit_message>
Release audited BantengPanel MVP with final clean-run evidence and demo package
</commit_message>
<xml_diff>
--- a/artifacts/pitch/BantengPanel_GENOHACK_2026_Audited.pptx
+++ b/artifacts/pitch/BantengPanel_GENOHACK_2026_Audited.pptx
@@ -2,23 +2,23 @@
 <file path=ppt/presentation.xml><?xml version="1.0" encoding="utf-8"?>
 <p:presentation xmlns:p="http://schemas.openxmlformats.org/presentationml/2006/main">
   <p:sldMasterIdLst>
-    <p:sldMasterId xmlns:r="http://schemas.openxmlformats.org/officeDocument/2006/relationships" id="2147483648" r:id="R14aae10bae4a48d1"/>
+    <p:sldMasterId xmlns:r="http://schemas.openxmlformats.org/officeDocument/2006/relationships" id="2147483648" r:id="R1fac208d37bc4b1d"/>
   </p:sldMasterIdLst>
   <p:notesMasterIdLst>
-    <p:notesMasterId xmlns:r="http://schemas.openxmlformats.org/officeDocument/2006/relationships" r:id="Rc393a9bdead84e05"/>
+    <p:notesMasterId xmlns:r="http://schemas.openxmlformats.org/officeDocument/2006/relationships" r:id="R5366d5fed18f4c19"/>
   </p:notesMasterIdLst>
   <p:sldIdLst>
-    <p:sldId xmlns:r="http://schemas.openxmlformats.org/officeDocument/2006/relationships" id="256" r:id="Rb7c27a88473f4e38"/>
-    <p:sldId xmlns:r="http://schemas.openxmlformats.org/officeDocument/2006/relationships" id="257" r:id="Rc66071e45ab34273"/>
-    <p:sldId xmlns:r="http://schemas.openxmlformats.org/officeDocument/2006/relationships" id="258" r:id="Rc4d08328339e45dc"/>
-    <p:sldId xmlns:r="http://schemas.openxmlformats.org/officeDocument/2006/relationships" id="259" r:id="Re699421af17643d3"/>
-    <p:sldId xmlns:r="http://schemas.openxmlformats.org/officeDocument/2006/relationships" id="260" r:id="Re745be910a9f44b3"/>
-    <p:sldId xmlns:r="http://schemas.openxmlformats.org/officeDocument/2006/relationships" id="261" r:id="R4d8f08b00dd342d8"/>
-    <p:sldId xmlns:r="http://schemas.openxmlformats.org/officeDocument/2006/relationships" id="262" r:id="Ra17ec632f37c44ba"/>
-    <p:sldId xmlns:r="http://schemas.openxmlformats.org/officeDocument/2006/relationships" id="263" r:id="R4a7dca13e2d048ad"/>
-    <p:sldId xmlns:r="http://schemas.openxmlformats.org/officeDocument/2006/relationships" id="264" r:id="R4e14df8ba0c94460"/>
-    <p:sldId xmlns:r="http://schemas.openxmlformats.org/officeDocument/2006/relationships" id="265" r:id="R3b03d90d921b4d63"/>
-    <p:sldId xmlns:r="http://schemas.openxmlformats.org/officeDocument/2006/relationships" id="266" r:id="R74cea81f2a4f4512"/>
+    <p:sldId xmlns:r="http://schemas.openxmlformats.org/officeDocument/2006/relationships" id="256" r:id="R7338015a8a844c93"/>
+    <p:sldId xmlns:r="http://schemas.openxmlformats.org/officeDocument/2006/relationships" id="257" r:id="R091da186fdf4453b"/>
+    <p:sldId xmlns:r="http://schemas.openxmlformats.org/officeDocument/2006/relationships" id="258" r:id="Rd1116c4d335947ee"/>
+    <p:sldId xmlns:r="http://schemas.openxmlformats.org/officeDocument/2006/relationships" id="259" r:id="R66787e24daac4e9f"/>
+    <p:sldId xmlns:r="http://schemas.openxmlformats.org/officeDocument/2006/relationships" id="260" r:id="Ra8a6288fd48941f5"/>
+    <p:sldId xmlns:r="http://schemas.openxmlformats.org/officeDocument/2006/relationships" id="261" r:id="R1111877ce27841c4"/>
+    <p:sldId xmlns:r="http://schemas.openxmlformats.org/officeDocument/2006/relationships" id="262" r:id="R0412e3098ef84027"/>
+    <p:sldId xmlns:r="http://schemas.openxmlformats.org/officeDocument/2006/relationships" id="263" r:id="R4438b2d6f0414e83"/>
+    <p:sldId xmlns:r="http://schemas.openxmlformats.org/officeDocument/2006/relationships" id="264" r:id="Rdbaa37998c4444fe"/>
+    <p:sldId xmlns:r="http://schemas.openxmlformats.org/officeDocument/2006/relationships" id="265" r:id="R77a61a72047a4a15"/>
+    <p:sldId xmlns:r="http://schemas.openxmlformats.org/officeDocument/2006/relationships" id="266" r:id="R92d0da8fc03c421f"/>
   </p:sldIdLst>
   <p:sldSz cx="12192000" cy="6858000"/>
   <p:notesSz cx="6858000" cy="9144000"/>
@@ -477,7 +477,7 @@
           </a:p>
           <a:p xmlns:a="http://schemas.openxmlformats.org/drawingml/2006/main">
             <a:r>
-              <a:t>Angka ilmiah: artifacts/public/pitch_facts.json; source 2796296a92c1f736faaa71f0f9b1138ccafd4a61.</a:t>
+              <a:t>Angka ilmiah: artifacts/public/pitch_facts.json; source fb784d54af1646058a083dfee05bd0a40879444d.</a:t>
             </a:r>
           </a:p>
         </p:txBody>
@@ -572,7 +572,7 @@
           </a:p>
           <a:p xmlns:a="http://schemas.openxmlformats.org/drawingml/2006/main">
             <a:r>
-              <a:t>Angka ilmiah: artifacts/public/pitch_facts.json; source 2796296a92c1f736faaa71f0f9b1138ccafd4a61.</a:t>
+              <a:t>Angka ilmiah: artifacts/public/pitch_facts.json; source fb784d54af1646058a083dfee05bd0a40879444d.</a:t>
             </a:r>
           </a:p>
         </p:txBody>
@@ -667,7 +667,7 @@
           </a:p>
           <a:p xmlns:a="http://schemas.openxmlformats.org/drawingml/2006/main">
             <a:r>
-              <a:t>Angka ilmiah: artifacts/public/pitch_facts.json; source 2796296a92c1f736faaa71f0f9b1138ccafd4a61.</a:t>
+              <a:t>Angka ilmiah: artifacts/public/pitch_facts.json; source fb784d54af1646058a083dfee05bd0a40879444d.</a:t>
             </a:r>
           </a:p>
         </p:txBody>
@@ -762,7 +762,7 @@
           </a:p>
           <a:p xmlns:a="http://schemas.openxmlformats.org/drawingml/2006/main">
             <a:r>
-              <a:t>Angka ilmiah: artifacts/public/pitch_facts.json; source 2796296a92c1f736faaa71f0f9b1138ccafd4a61.</a:t>
+              <a:t>Angka ilmiah: artifacts/public/pitch_facts.json; source fb784d54af1646058a083dfee05bd0a40879444d.</a:t>
             </a:r>
           </a:p>
         </p:txBody>
@@ -857,7 +857,7 @@
           </a:p>
           <a:p xmlns:a="http://schemas.openxmlformats.org/drawingml/2006/main">
             <a:r>
-              <a:t>Angka ilmiah: artifacts/public/pitch_facts.json; source 2796296a92c1f736faaa71f0f9b1138ccafd4a61.</a:t>
+              <a:t>Angka ilmiah: artifacts/public/pitch_facts.json; source fb784d54af1646058a083dfee05bd0a40879444d.</a:t>
             </a:r>
           </a:p>
         </p:txBody>
@@ -952,7 +952,7 @@
           </a:p>
           <a:p xmlns:a="http://schemas.openxmlformats.org/drawingml/2006/main">
             <a:r>
-              <a:t>Angka ilmiah: artifacts/public/pitch_facts.json; source 2796296a92c1f736faaa71f0f9b1138ccafd4a61.</a:t>
+              <a:t>Angka ilmiah: artifacts/public/pitch_facts.json; source fb784d54af1646058a083dfee05bd0a40879444d.</a:t>
             </a:r>
           </a:p>
         </p:txBody>
@@ -1047,7 +1047,7 @@
           </a:p>
           <a:p xmlns:a="http://schemas.openxmlformats.org/drawingml/2006/main">
             <a:r>
-              <a:t>Angka ilmiah: artifacts/public/pitch_facts.json; source 2796296a92c1f736faaa71f0f9b1138ccafd4a61.</a:t>
+              <a:t>Angka ilmiah: artifacts/public/pitch_facts.json; source fb784d54af1646058a083dfee05bd0a40879444d.</a:t>
             </a:r>
           </a:p>
         </p:txBody>
@@ -1142,7 +1142,7 @@
           </a:p>
           <a:p xmlns:a="http://schemas.openxmlformats.org/drawingml/2006/main">
             <a:r>
-              <a:t>Angka ilmiah: artifacts/public/pitch_facts.json; source 2796296a92c1f736faaa71f0f9b1138ccafd4a61.</a:t>
+              <a:t>Angka ilmiah: artifacts/public/pitch_facts.json; source fb784d54af1646058a083dfee05bd0a40879444d.</a:t>
             </a:r>
           </a:p>
         </p:txBody>
@@ -1237,7 +1237,7 @@
           </a:p>
           <a:p xmlns:a="http://schemas.openxmlformats.org/drawingml/2006/main">
             <a:r>
-              <a:t>Angka ilmiah: artifacts/public/pitch_facts.json; source 2796296a92c1f736faaa71f0f9b1138ccafd4a61.</a:t>
+              <a:t>Angka ilmiah: artifacts/public/pitch_facts.json; source fb784d54af1646058a083dfee05bd0a40879444d.</a:t>
             </a:r>
           </a:p>
         </p:txBody>
@@ -1332,7 +1332,7 @@
           </a:p>
           <a:p xmlns:a="http://schemas.openxmlformats.org/drawingml/2006/main">
             <a:r>
-              <a:t>Angka ilmiah: artifacts/public/pitch_facts.json; source 2796296a92c1f736faaa71f0f9b1138ccafd4a61.</a:t>
+              <a:t>Angka ilmiah: artifacts/public/pitch_facts.json; source fb784d54af1646058a083dfee05bd0a40879444d.</a:t>
             </a:r>
           </a:p>
         </p:txBody>
@@ -1427,7 +1427,7 @@
           </a:p>
           <a:p xmlns:a="http://schemas.openxmlformats.org/drawingml/2006/main">
             <a:r>
-              <a:t>Angka ilmiah: artifacts/public/pitch_facts.json; source 2796296a92c1f736faaa71f0f9b1138ccafd4a61.</a:t>
+              <a:t>Angka ilmiah: artifacts/public/pitch_facts.json; source fb784d54af1646058a083dfee05bd0a40879444d.</a:t>
             </a:r>
           </a:p>
         </p:txBody>
@@ -1474,7 +1474,7 @@
           <p:cNvPr id="3" name="Title">
             <a:extLst xmlns:a="http://schemas.openxmlformats.org/drawingml/2006/main">
               <a:ext uri="{FF2B5EF4-FFF2-40B4-BE49-F238E27FC236}">
-                <a16:creationId xmlns:a16="http://schemas.microsoft.com/office/drawing/2014/main" id="{DD0D4C0D-AE8E-4D3B-AFF0-DDD93E08F722}"/>
+                <a16:creationId xmlns:a16="http://schemas.microsoft.com/office/drawing/2014/main" id="{93A00C1F-B06F-4060-80E6-F4D9A8B04B83}"/>
               </a:ext>
             </a:extLst>
           </p:cNvPr>
@@ -1703,7 +1703,7 @@
           <p:cNvPr id="2" name="Subtitle">
             <a:extLst xmlns:a="http://schemas.openxmlformats.org/drawingml/2006/main">
               <a:ext uri="{FF2B5EF4-FFF2-40B4-BE49-F238E27FC236}">
-                <a16:creationId xmlns:a16="http://schemas.microsoft.com/office/drawing/2014/main" id="{F7331C7E-4004-4C5D-B385-0409EDB3EFEA}"/>
+                <a16:creationId xmlns:a16="http://schemas.microsoft.com/office/drawing/2014/main" id="{C19E32A1-EC77-4483-8E19-74226461181A}"/>
               </a:ext>
             </a:extLst>
           </p:cNvPr>
@@ -1949,7 +1949,7 @@
           <p:cNvPr id="2" name="Section title">
             <a:extLst xmlns:a="http://schemas.openxmlformats.org/drawingml/2006/main">
               <a:ext uri="{FF2B5EF4-FFF2-40B4-BE49-F238E27FC236}">
-                <a16:creationId xmlns:a16="http://schemas.microsoft.com/office/drawing/2014/main" id="{2CE39DA4-B626-4103-8789-25C21FD86EC6}"/>
+                <a16:creationId xmlns:a16="http://schemas.microsoft.com/office/drawing/2014/main" id="{13399BAB-8BD8-4EAF-AD34-3A76F4932B56}"/>
               </a:ext>
             </a:extLst>
           </p:cNvPr>
@@ -2195,7 +2195,7 @@
           <p:cNvPr id="3" name="Title">
             <a:extLst xmlns:a="http://schemas.openxmlformats.org/drawingml/2006/main">
               <a:ext uri="{FF2B5EF4-FFF2-40B4-BE49-F238E27FC236}">
-                <a16:creationId xmlns:a16="http://schemas.microsoft.com/office/drawing/2014/main" id="{D5F7D704-1565-4A21-98FE-19E6DB404F78}"/>
+                <a16:creationId xmlns:a16="http://schemas.microsoft.com/office/drawing/2014/main" id="{DF5724F8-C967-43F1-A4AE-2650BDE889F1}"/>
               </a:ext>
             </a:extLst>
           </p:cNvPr>
@@ -2424,7 +2424,7 @@
           <p:cNvPr id="2" name="Body">
             <a:extLst xmlns:a="http://schemas.openxmlformats.org/drawingml/2006/main">
               <a:ext uri="{FF2B5EF4-FFF2-40B4-BE49-F238E27FC236}">
-                <a16:creationId xmlns:a16="http://schemas.microsoft.com/office/drawing/2014/main" id="{029F3B6F-C036-469E-8B72-F2913A6725E3}"/>
+                <a16:creationId xmlns:a16="http://schemas.microsoft.com/office/drawing/2014/main" id="{D4C2E042-D6CD-4AC9-8E70-29735768A79A}"/>
               </a:ext>
             </a:extLst>
           </p:cNvPr>
@@ -2670,7 +2670,7 @@
           <p:cNvPr id="4" name="Title">
             <a:extLst xmlns:a="http://schemas.openxmlformats.org/drawingml/2006/main">
               <a:ext uri="{FF2B5EF4-FFF2-40B4-BE49-F238E27FC236}">
-                <a16:creationId xmlns:a16="http://schemas.microsoft.com/office/drawing/2014/main" id="{F6F24B4D-81B7-4929-9B0A-3435DD79F8E6}"/>
+                <a16:creationId xmlns:a16="http://schemas.microsoft.com/office/drawing/2014/main" id="{4E0426AD-464E-4018-975B-2724C6C6952B}"/>
               </a:ext>
             </a:extLst>
           </p:cNvPr>
@@ -2899,7 +2899,7 @@
           <p:cNvPr id="2" name="Left column">
             <a:extLst xmlns:a="http://schemas.openxmlformats.org/drawingml/2006/main">
               <a:ext uri="{FF2B5EF4-FFF2-40B4-BE49-F238E27FC236}">
-                <a16:creationId xmlns:a16="http://schemas.microsoft.com/office/drawing/2014/main" id="{C056369D-A772-4E8B-8716-865F6BBBFE13}"/>
+                <a16:creationId xmlns:a16="http://schemas.microsoft.com/office/drawing/2014/main" id="{D1D2F8E3-E574-4382-946F-61154D6D24A5}"/>
               </a:ext>
             </a:extLst>
           </p:cNvPr>
@@ -3128,7 +3128,7 @@
           <p:cNvPr id="3" name="Right column">
             <a:extLst xmlns:a="http://schemas.openxmlformats.org/drawingml/2006/main">
               <a:ext uri="{FF2B5EF4-FFF2-40B4-BE49-F238E27FC236}">
-                <a16:creationId xmlns:a16="http://schemas.microsoft.com/office/drawing/2014/main" id="{6521B7EE-DF49-49DC-A5CE-763EA6113D35}"/>
+                <a16:creationId xmlns:a16="http://schemas.microsoft.com/office/drawing/2014/main" id="{A4F71DEA-565C-44FB-AD17-882918869E1E}"/>
               </a:ext>
             </a:extLst>
           </p:cNvPr>
@@ -3374,7 +3374,7 @@
           <p:cNvPr id="3" name="Title">
             <a:extLst xmlns:a="http://schemas.openxmlformats.org/drawingml/2006/main">
               <a:ext uri="{FF2B5EF4-FFF2-40B4-BE49-F238E27FC236}">
-                <a16:creationId xmlns:a16="http://schemas.microsoft.com/office/drawing/2014/main" id="{0933A0C6-DEF9-408A-9B06-1B9B13E4C6D6}"/>
+                <a16:creationId xmlns:a16="http://schemas.microsoft.com/office/drawing/2014/main" id="{099B6094-36F3-4BF9-94FE-37081F7E4BF5}"/>
               </a:ext>
             </a:extLst>
           </p:cNvPr>
@@ -3603,7 +3603,7 @@
           <p:cNvPr id="2" name="Left column">
             <a:extLst xmlns:a="http://schemas.openxmlformats.org/drawingml/2006/main">
               <a:ext uri="{FF2B5EF4-FFF2-40B4-BE49-F238E27FC236}">
-                <a16:creationId xmlns:a16="http://schemas.microsoft.com/office/drawing/2014/main" id="{D9E554B7-DBDD-4F65-9765-BD5C2D171166}"/>
+                <a16:creationId xmlns:a16="http://schemas.microsoft.com/office/drawing/2014/main" id="{E39770E4-EC09-4026-A695-E5E44AAE70D2}"/>
               </a:ext>
             </a:extLst>
           </p:cNvPr>
@@ -3870,12 +3870,12 @@
   </p:cSld>
   <p:clrMap bg1="lt1" tx1="dk1" bg2="lt2" tx2="dk2" accent1="accent1" accent2="accent2" accent3="accent3" accent4="accent4" accent5="accent5" accent6="accent6" hlink="hlink" folHlink="folHlink"/>
   <p:sldLayoutIdLst>
-    <p:sldLayoutId xmlns:r="http://schemas.openxmlformats.org/officeDocument/2006/relationships" id="2147483649" r:id="R39311cd9442941e5"/>
-    <p:sldLayoutId xmlns:r="http://schemas.openxmlformats.org/officeDocument/2006/relationships" id="2147483650" r:id="Rb5f11a6ec1f34b10"/>
-    <p:sldLayoutId xmlns:r="http://schemas.openxmlformats.org/officeDocument/2006/relationships" id="2147483651" r:id="R41afe42e1eb940d2"/>
-    <p:sldLayoutId xmlns:r="http://schemas.openxmlformats.org/officeDocument/2006/relationships" id="2147483652" r:id="R2a3c60bc8f2b47dc"/>
-    <p:sldLayoutId xmlns:r="http://schemas.openxmlformats.org/officeDocument/2006/relationships" id="2147483653" r:id="R0cc86a14ef84478c"/>
-    <p:sldLayoutId xmlns:r="http://schemas.openxmlformats.org/officeDocument/2006/relationships" id="2147483654" r:id="R5c6b7162fb38411a"/>
+    <p:sldLayoutId xmlns:r="http://schemas.openxmlformats.org/officeDocument/2006/relationships" id="2147483649" r:id="Re0b6d49d35d94145"/>
+    <p:sldLayoutId xmlns:r="http://schemas.openxmlformats.org/officeDocument/2006/relationships" id="2147483650" r:id="R5953f3ad32b54e89"/>
+    <p:sldLayoutId xmlns:r="http://schemas.openxmlformats.org/officeDocument/2006/relationships" id="2147483651" r:id="Rc2854849333c4c33"/>
+    <p:sldLayoutId xmlns:r="http://schemas.openxmlformats.org/officeDocument/2006/relationships" id="2147483652" r:id="R4b0a8f38c6e34fa6"/>
+    <p:sldLayoutId xmlns:r="http://schemas.openxmlformats.org/officeDocument/2006/relationships" id="2147483653" r:id="R3f3e8e2fd3ec4255"/>
+    <p:sldLayoutId xmlns:r="http://schemas.openxmlformats.org/officeDocument/2006/relationships" id="2147483654" r:id="Re1d369e4876146f7"/>
   </p:sldLayoutIdLst>
   <p:txStyles>
     <p:titleStyle>
@@ -4982,7 +4982,7 @@
           <p:cNvPr id="9" name="">
             <a:extLst xmlns:a="http://schemas.openxmlformats.org/drawingml/2006/main">
               <a:ext uri="{FF2B5EF4-FFF2-40B4-BE49-F238E27FC236}">
-                <a16:creationId xmlns:a16="http://schemas.microsoft.com/office/drawing/2014/main" id="{504CF07D-7208-4AC1-812F-58A73D62D881}"/>
+                <a16:creationId xmlns:a16="http://schemas.microsoft.com/office/drawing/2014/main" id="{0FD2D6AD-DC5A-4E84-9889-76460873248E}"/>
               </a:ext>
             </a:extLst>
           </p:cNvPr>
@@ -5140,7 +5140,7 @@
           <p:cNvPr id="2" name="">
             <a:extLst xmlns:a="http://schemas.openxmlformats.org/drawingml/2006/main">
               <a:ext uri="{FF2B5EF4-FFF2-40B4-BE49-F238E27FC236}">
-                <a16:creationId xmlns:a16="http://schemas.microsoft.com/office/drawing/2014/main" id="{7D4B1F34-96D6-4C49-ABB6-9F6F9B5A49F4}"/>
+                <a16:creationId xmlns:a16="http://schemas.microsoft.com/office/drawing/2014/main" id="{A1893A42-70C1-48DE-B634-CEA8C079E517}"/>
               </a:ext>
             </a:extLst>
           </p:cNvPr>
@@ -5298,7 +5298,7 @@
           <p:cNvPr id="3" name="">
             <a:extLst xmlns:a="http://schemas.openxmlformats.org/drawingml/2006/main">
               <a:ext uri="{FF2B5EF4-FFF2-40B4-BE49-F238E27FC236}">
-                <a16:creationId xmlns:a16="http://schemas.microsoft.com/office/drawing/2014/main" id="{E107628F-BD57-4003-8D1C-7C41AB3E39B0}"/>
+                <a16:creationId xmlns:a16="http://schemas.microsoft.com/office/drawing/2014/main" id="{8AA10868-3028-4F2F-B1E7-1C55600DA11F}"/>
               </a:ext>
             </a:extLst>
           </p:cNvPr>
@@ -5456,7 +5456,7 @@
           <p:cNvPr id="4" name="">
             <a:extLst xmlns:a="http://schemas.openxmlformats.org/drawingml/2006/main">
               <a:ext uri="{FF2B5EF4-FFF2-40B4-BE49-F238E27FC236}">
-                <a16:creationId xmlns:a16="http://schemas.microsoft.com/office/drawing/2014/main" id="{F84F9A26-A882-4E5A-AE80-4FEA0A93C0AC}"/>
+                <a16:creationId xmlns:a16="http://schemas.microsoft.com/office/drawing/2014/main" id="{13BD2BF0-F704-410A-8C09-EB62A2513BE0}"/>
               </a:ext>
             </a:extLst>
           </p:cNvPr>
@@ -5614,7 +5614,7 @@
           <p:cNvPr id="5" name="">
             <a:extLst xmlns:a="http://schemas.openxmlformats.org/drawingml/2006/main">
               <a:ext uri="{FF2B5EF4-FFF2-40B4-BE49-F238E27FC236}">
-                <a16:creationId xmlns:a16="http://schemas.microsoft.com/office/drawing/2014/main" id="{93DC4AC6-4C89-4459-A58E-8910BAC3F365}"/>
+                <a16:creationId xmlns:a16="http://schemas.microsoft.com/office/drawing/2014/main" id="{91A3F41F-3C50-4177-9F6E-44BA5BB83E27}"/>
               </a:ext>
             </a:extLst>
           </p:cNvPr>
@@ -5795,7 +5795,7 @@
           <p:cNvPr id="6" name="">
             <a:extLst xmlns:a="http://schemas.openxmlformats.org/drawingml/2006/main">
               <a:ext uri="{FF2B5EF4-FFF2-40B4-BE49-F238E27FC236}">
-                <a16:creationId xmlns:a16="http://schemas.microsoft.com/office/drawing/2014/main" id="{C23FF8F3-07F9-447A-9DB1-2662D29881C4}"/>
+                <a16:creationId xmlns:a16="http://schemas.microsoft.com/office/drawing/2014/main" id="{A005EFC4-EF4F-4B4B-8D33-BF7FABD78340}"/>
               </a:ext>
             </a:extLst>
           </p:cNvPr>
@@ -5953,7 +5953,7 @@
           <p:cNvPr id="7" name="">
             <a:extLst xmlns:a="http://schemas.openxmlformats.org/drawingml/2006/main">
               <a:ext uri="{FF2B5EF4-FFF2-40B4-BE49-F238E27FC236}">
-                <a16:creationId xmlns:a16="http://schemas.microsoft.com/office/drawing/2014/main" id="{E9D6B3B7-1FE5-45B1-8CB9-18C286D32EA5}"/>
+                <a16:creationId xmlns:a16="http://schemas.microsoft.com/office/drawing/2014/main" id="{702EEF7E-1306-428D-9BB9-D0D09C369BE9}"/>
               </a:ext>
             </a:extLst>
           </p:cNvPr>
@@ -6111,7 +6111,7 @@
           <p:cNvPr id="8" name="">
             <a:extLst xmlns:a="http://schemas.openxmlformats.org/drawingml/2006/main">
               <a:ext uri="{FF2B5EF4-FFF2-40B4-BE49-F238E27FC236}">
-                <a16:creationId xmlns:a16="http://schemas.microsoft.com/office/drawing/2014/main" id="{FB960C71-CC57-4B6F-97FA-A0FD24BDE48E}"/>
+                <a16:creationId xmlns:a16="http://schemas.microsoft.com/office/drawing/2014/main" id="{2FF42CAD-6487-460A-9418-B6E258C4D1CC}"/>
               </a:ext>
             </a:extLst>
           </p:cNvPr>
@@ -6267,7 +6267,7 @@
     </p:spTree>
     <p:extLst>
       <p:ext uri="{BB962C8B-B14F-4D97-AF65-F5344CB8AC3E}">
-        <p14:creationId xmlns:p14="http://schemas.microsoft.com/office/powerpoint/2010/main" val="1586399743"/>
+        <p14:creationId xmlns:p14="http://schemas.microsoft.com/office/powerpoint/2010/main" val="1365239496"/>
       </p:ext>
     </p:extLst>
   </p:cSld>
@@ -6298,7 +6298,7 @@
           <p:cNvPr id="16" name="">
             <a:extLst xmlns:a="http://schemas.openxmlformats.org/drawingml/2006/main">
               <a:ext uri="{FF2B5EF4-FFF2-40B4-BE49-F238E27FC236}">
-                <a16:creationId xmlns:a16="http://schemas.microsoft.com/office/drawing/2014/main" id="{88A0E87A-C116-4958-AB74-EED7D1DB3732}"/>
+                <a16:creationId xmlns:a16="http://schemas.microsoft.com/office/drawing/2014/main" id="{AD9EDBC0-5D78-4619-B9F0-D3291156F6D1}"/>
               </a:ext>
             </a:extLst>
           </p:cNvPr>
@@ -6456,7 +6456,7 @@
           <p:cNvPr id="2" name="">
             <a:extLst xmlns:a="http://schemas.openxmlformats.org/drawingml/2006/main">
               <a:ext uri="{FF2B5EF4-FFF2-40B4-BE49-F238E27FC236}">
-                <a16:creationId xmlns:a16="http://schemas.microsoft.com/office/drawing/2014/main" id="{5EE99DF6-04FB-46E7-8801-C07F65BF208B}"/>
+                <a16:creationId xmlns:a16="http://schemas.microsoft.com/office/drawing/2014/main" id="{1D4405B9-CA4C-4C5A-943A-1CD6AC482FAD}"/>
               </a:ext>
             </a:extLst>
           </p:cNvPr>
@@ -6614,7 +6614,7 @@
           <p:cNvPr id="3" name="">
             <a:extLst xmlns:a="http://schemas.openxmlformats.org/drawingml/2006/main">
               <a:ext uri="{FF2B5EF4-FFF2-40B4-BE49-F238E27FC236}">
-                <a16:creationId xmlns:a16="http://schemas.microsoft.com/office/drawing/2014/main" id="{6E1E8D9B-DA20-4EA1-87A2-1E431CDFDEE2}"/>
+                <a16:creationId xmlns:a16="http://schemas.microsoft.com/office/drawing/2014/main" id="{BAF4863B-6206-40F9-9665-B316AC1FC5D9}"/>
               </a:ext>
             </a:extLst>
           </p:cNvPr>
@@ -6772,7 +6772,7 @@
           <p:cNvPr id="4" name="">
             <a:extLst xmlns:a="http://schemas.openxmlformats.org/drawingml/2006/main">
               <a:ext uri="{FF2B5EF4-FFF2-40B4-BE49-F238E27FC236}">
-                <a16:creationId xmlns:a16="http://schemas.microsoft.com/office/drawing/2014/main" id="{4ACCA255-2CA8-4577-BBEF-54EDCFE0011D}"/>
+                <a16:creationId xmlns:a16="http://schemas.microsoft.com/office/drawing/2014/main" id="{9BFD4205-941E-4AB7-A172-D5F3D708DC68}"/>
               </a:ext>
             </a:extLst>
           </p:cNvPr>
@@ -6930,7 +6930,7 @@
           <p:cNvPr id="5" name="">
             <a:extLst xmlns:a="http://schemas.openxmlformats.org/drawingml/2006/main">
               <a:ext uri="{FF2B5EF4-FFF2-40B4-BE49-F238E27FC236}">
-                <a16:creationId xmlns:a16="http://schemas.microsoft.com/office/drawing/2014/main" id="{C5CA6B25-9C96-4DD5-94F5-9D7AABAF47FE}"/>
+                <a16:creationId xmlns:a16="http://schemas.microsoft.com/office/drawing/2014/main" id="{4D7DEAF4-3C1A-42F3-8DA6-A444BE6143E9}"/>
               </a:ext>
             </a:extLst>
           </p:cNvPr>
@@ -7088,7 +7088,7 @@
           <p:cNvPr id="6" name="">
             <a:extLst xmlns:a="http://schemas.openxmlformats.org/drawingml/2006/main">
               <a:ext uri="{FF2B5EF4-FFF2-40B4-BE49-F238E27FC236}">
-                <a16:creationId xmlns:a16="http://schemas.microsoft.com/office/drawing/2014/main" id="{07F3EC02-CB92-4E84-8ADA-125EB1B38E5A}"/>
+                <a16:creationId xmlns:a16="http://schemas.microsoft.com/office/drawing/2014/main" id="{1496F67C-FD18-43CE-8A13-C010C161ACA0}"/>
               </a:ext>
             </a:extLst>
           </p:cNvPr>
@@ -7246,7 +7246,7 @@
           <p:cNvPr id="7" name="">
             <a:extLst xmlns:a="http://schemas.openxmlformats.org/drawingml/2006/main">
               <a:ext uri="{FF2B5EF4-FFF2-40B4-BE49-F238E27FC236}">
-                <a16:creationId xmlns:a16="http://schemas.microsoft.com/office/drawing/2014/main" id="{88CA0CE7-CC1E-4A5D-BC2F-7FBB73C413CA}"/>
+                <a16:creationId xmlns:a16="http://schemas.microsoft.com/office/drawing/2014/main" id="{DF80B354-D9C4-4C39-BA9C-F3F68F17DCD0}"/>
               </a:ext>
             </a:extLst>
           </p:cNvPr>
@@ -7404,7 +7404,7 @@
           <p:cNvPr id="8" name="">
             <a:extLst xmlns:a="http://schemas.openxmlformats.org/drawingml/2006/main">
               <a:ext uri="{FF2B5EF4-FFF2-40B4-BE49-F238E27FC236}">
-                <a16:creationId xmlns:a16="http://schemas.microsoft.com/office/drawing/2014/main" id="{B9D75118-FA7D-456D-B6D9-7DEC8DE0B777}"/>
+                <a16:creationId xmlns:a16="http://schemas.microsoft.com/office/drawing/2014/main" id="{A504633C-5AC9-419D-B65C-65799EC409D9}"/>
               </a:ext>
             </a:extLst>
           </p:cNvPr>
@@ -7562,7 +7562,7 @@
           <p:cNvPr id="9" name="">
             <a:extLst xmlns:a="http://schemas.openxmlformats.org/drawingml/2006/main">
               <a:ext uri="{FF2B5EF4-FFF2-40B4-BE49-F238E27FC236}">
-                <a16:creationId xmlns:a16="http://schemas.microsoft.com/office/drawing/2014/main" id="{D5E74AEE-27CF-4093-B0EE-86C7B065C235}"/>
+                <a16:creationId xmlns:a16="http://schemas.microsoft.com/office/drawing/2014/main" id="{027D4D2E-1AEC-44B9-BD21-D435437E434E}"/>
               </a:ext>
             </a:extLst>
           </p:cNvPr>
@@ -7720,7 +7720,7 @@
           <p:cNvPr id="10" name="">
             <a:extLst xmlns:a="http://schemas.openxmlformats.org/drawingml/2006/main">
               <a:ext uri="{FF2B5EF4-FFF2-40B4-BE49-F238E27FC236}">
-                <a16:creationId xmlns:a16="http://schemas.microsoft.com/office/drawing/2014/main" id="{880E0489-CF9D-48C3-913F-45A2AF59A76C}"/>
+                <a16:creationId xmlns:a16="http://schemas.microsoft.com/office/drawing/2014/main" id="{9623F80C-8649-4BB5-9401-F8AAA22DF72A}"/>
               </a:ext>
             </a:extLst>
           </p:cNvPr>
@@ -7878,7 +7878,7 @@
           <p:cNvPr id="11" name="">
             <a:extLst xmlns:a="http://schemas.openxmlformats.org/drawingml/2006/main">
               <a:ext uri="{FF2B5EF4-FFF2-40B4-BE49-F238E27FC236}">
-                <a16:creationId xmlns:a16="http://schemas.microsoft.com/office/drawing/2014/main" id="{C15C560B-B7B1-4568-BBCB-9AE82DA9DF8B}"/>
+                <a16:creationId xmlns:a16="http://schemas.microsoft.com/office/drawing/2014/main" id="{2D842415-6A70-4F04-A99C-CE77E497CE9D}"/>
               </a:ext>
             </a:extLst>
           </p:cNvPr>
@@ -8059,7 +8059,7 @@
           <p:cNvPr id="12" name="">
             <a:extLst xmlns:a="http://schemas.openxmlformats.org/drawingml/2006/main">
               <a:ext uri="{FF2B5EF4-FFF2-40B4-BE49-F238E27FC236}">
-                <a16:creationId xmlns:a16="http://schemas.microsoft.com/office/drawing/2014/main" id="{B95B47FC-E015-4FE4-9751-8B61EA1B0911}"/>
+                <a16:creationId xmlns:a16="http://schemas.microsoft.com/office/drawing/2014/main" id="{93423103-6CC0-4200-BB6A-FD21C0D9E992}"/>
               </a:ext>
             </a:extLst>
           </p:cNvPr>
@@ -8217,7 +8217,7 @@
           <p:cNvPr id="13" name="">
             <a:extLst xmlns:a="http://schemas.openxmlformats.org/drawingml/2006/main">
               <a:ext uri="{FF2B5EF4-FFF2-40B4-BE49-F238E27FC236}">
-                <a16:creationId xmlns:a16="http://schemas.microsoft.com/office/drawing/2014/main" id="{06853C29-7C5A-4147-AD6C-7DA850A597C5}"/>
+                <a16:creationId xmlns:a16="http://schemas.microsoft.com/office/drawing/2014/main" id="{9A4AF0F3-4134-481A-A7C9-18CA5CF1CDD5}"/>
               </a:ext>
             </a:extLst>
           </p:cNvPr>
@@ -8421,7 +8421,7 @@
           <p:cNvPr id="14" name="">
             <a:extLst xmlns:a="http://schemas.openxmlformats.org/drawingml/2006/main">
               <a:ext uri="{FF2B5EF4-FFF2-40B4-BE49-F238E27FC236}">
-                <a16:creationId xmlns:a16="http://schemas.microsoft.com/office/drawing/2014/main" id="{9E492D2E-4DF1-4E6C-9E92-B54B238F3DC6}"/>
+                <a16:creationId xmlns:a16="http://schemas.microsoft.com/office/drawing/2014/main" id="{8BF7FED8-375E-4C38-84A2-6ACBF9519FBD}"/>
               </a:ext>
             </a:extLst>
           </p:cNvPr>
@@ -8579,7 +8579,7 @@
           <p:cNvPr id="15" name="">
             <a:extLst xmlns:a="http://schemas.openxmlformats.org/drawingml/2006/main">
               <a:ext uri="{FF2B5EF4-FFF2-40B4-BE49-F238E27FC236}">
-                <a16:creationId xmlns:a16="http://schemas.microsoft.com/office/drawing/2014/main" id="{CBC2F395-A241-4B59-8645-5FA35E68208E}"/>
+                <a16:creationId xmlns:a16="http://schemas.microsoft.com/office/drawing/2014/main" id="{A089D285-6A4D-4140-9028-9E7B7AF41900}"/>
               </a:ext>
             </a:extLst>
           </p:cNvPr>
@@ -8735,7 +8735,7 @@
     </p:spTree>
     <p:extLst>
       <p:ext uri="{BB962C8B-B14F-4D97-AF65-F5344CB8AC3E}">
-        <p14:creationId xmlns:p14="http://schemas.microsoft.com/office/powerpoint/2010/main" val="1284997983"/>
+        <p14:creationId xmlns:p14="http://schemas.microsoft.com/office/powerpoint/2010/main" val="2112782237"/>
       </p:ext>
     </p:extLst>
   </p:cSld>
@@ -8766,7 +8766,7 @@
           <p:cNvPr id="13" name="">
             <a:extLst xmlns:a="http://schemas.openxmlformats.org/drawingml/2006/main">
               <a:ext uri="{FF2B5EF4-FFF2-40B4-BE49-F238E27FC236}">
-                <a16:creationId xmlns:a16="http://schemas.microsoft.com/office/drawing/2014/main" id="{F740D2B3-1FA3-4FF5-AADF-C1B1D91CB434}"/>
+                <a16:creationId xmlns:a16="http://schemas.microsoft.com/office/drawing/2014/main" id="{C04ADBF2-3B8E-47E5-BE27-44DC45BFC041}"/>
               </a:ext>
             </a:extLst>
           </p:cNvPr>
@@ -8924,7 +8924,7 @@
           <p:cNvPr id="2" name="">
             <a:extLst xmlns:a="http://schemas.openxmlformats.org/drawingml/2006/main">
               <a:ext uri="{FF2B5EF4-FFF2-40B4-BE49-F238E27FC236}">
-                <a16:creationId xmlns:a16="http://schemas.microsoft.com/office/drawing/2014/main" id="{EFD8AEDF-56E2-4E01-A73D-620BEB6DCDB3}"/>
+                <a16:creationId xmlns:a16="http://schemas.microsoft.com/office/drawing/2014/main" id="{0B280B20-15E7-4982-B629-5D2515FF5081}"/>
               </a:ext>
             </a:extLst>
           </p:cNvPr>
@@ -9082,7 +9082,7 @@
           <p:cNvPr id="3" name="">
             <a:extLst xmlns:a="http://schemas.openxmlformats.org/drawingml/2006/main">
               <a:ext uri="{FF2B5EF4-FFF2-40B4-BE49-F238E27FC236}">
-                <a16:creationId xmlns:a16="http://schemas.microsoft.com/office/drawing/2014/main" id="{9D93701F-8B69-4B28-8F94-D08CB00D8B48}"/>
+                <a16:creationId xmlns:a16="http://schemas.microsoft.com/office/drawing/2014/main" id="{56FE0B96-1178-4719-978C-5504234A7036}"/>
               </a:ext>
             </a:extLst>
           </p:cNvPr>
@@ -9240,7 +9240,7 @@
           <p:cNvPr id="4" name="">
             <a:extLst xmlns:a="http://schemas.openxmlformats.org/drawingml/2006/main">
               <a:ext uri="{FF2B5EF4-FFF2-40B4-BE49-F238E27FC236}">
-                <a16:creationId xmlns:a16="http://schemas.microsoft.com/office/drawing/2014/main" id="{6EE09D7C-44E8-4BE2-8505-E7401F01C9AA}"/>
+                <a16:creationId xmlns:a16="http://schemas.microsoft.com/office/drawing/2014/main" id="{1450B04E-3507-44EC-A3A4-AC4150E09ADD}"/>
               </a:ext>
             </a:extLst>
           </p:cNvPr>
@@ -9398,7 +9398,7 @@
           <p:cNvPr id="5" name="">
             <a:extLst xmlns:a="http://schemas.openxmlformats.org/drawingml/2006/main">
               <a:ext uri="{FF2B5EF4-FFF2-40B4-BE49-F238E27FC236}">
-                <a16:creationId xmlns:a16="http://schemas.microsoft.com/office/drawing/2014/main" id="{3D94388C-429F-4629-BA0F-61648F7790BE}"/>
+                <a16:creationId xmlns:a16="http://schemas.microsoft.com/office/drawing/2014/main" id="{0C9530F0-8C01-40A5-9528-6A89BB923202}"/>
               </a:ext>
             </a:extLst>
           </p:cNvPr>
@@ -9556,7 +9556,7 @@
           <p:cNvPr id="6" name="">
             <a:extLst xmlns:a="http://schemas.openxmlformats.org/drawingml/2006/main">
               <a:ext uri="{FF2B5EF4-FFF2-40B4-BE49-F238E27FC236}">
-                <a16:creationId xmlns:a16="http://schemas.microsoft.com/office/drawing/2014/main" id="{FD951803-18A1-4EFE-A81A-7D26224FA2AE}"/>
+                <a16:creationId xmlns:a16="http://schemas.microsoft.com/office/drawing/2014/main" id="{9D93DB31-3338-4D5F-AF0A-A317E77FBCCA}"/>
               </a:ext>
             </a:extLst>
           </p:cNvPr>
@@ -9714,7 +9714,7 @@
           <p:cNvPr id="7" name="">
             <a:extLst xmlns:a="http://schemas.openxmlformats.org/drawingml/2006/main">
               <a:ext uri="{FF2B5EF4-FFF2-40B4-BE49-F238E27FC236}">
-                <a16:creationId xmlns:a16="http://schemas.microsoft.com/office/drawing/2014/main" id="{029E8A37-7D29-4EE4-8704-EB8F29A0A506}"/>
+                <a16:creationId xmlns:a16="http://schemas.microsoft.com/office/drawing/2014/main" id="{EA8CED72-908A-4251-86C1-3F4CB0589F1C}"/>
               </a:ext>
             </a:extLst>
           </p:cNvPr>
@@ -9872,7 +9872,7 @@
           <p:cNvPr id="8" name="">
             <a:extLst xmlns:a="http://schemas.openxmlformats.org/drawingml/2006/main">
               <a:ext uri="{FF2B5EF4-FFF2-40B4-BE49-F238E27FC236}">
-                <a16:creationId xmlns:a16="http://schemas.microsoft.com/office/drawing/2014/main" id="{97B0A6EF-2E39-42C5-BB27-3E15F3423BFA}"/>
+                <a16:creationId xmlns:a16="http://schemas.microsoft.com/office/drawing/2014/main" id="{416A0376-B39E-4551-8766-B6F4E1F62556}"/>
               </a:ext>
             </a:extLst>
           </p:cNvPr>
@@ -10030,7 +10030,7 @@
           <p:cNvPr id="9" name="">
             <a:extLst xmlns:a="http://schemas.openxmlformats.org/drawingml/2006/main">
               <a:ext uri="{FF2B5EF4-FFF2-40B4-BE49-F238E27FC236}">
-                <a16:creationId xmlns:a16="http://schemas.microsoft.com/office/drawing/2014/main" id="{6DA66E90-2E6E-4CD1-847B-FD60E1F70C3E}"/>
+                <a16:creationId xmlns:a16="http://schemas.microsoft.com/office/drawing/2014/main" id="{1270C6C1-2B46-460C-8BA6-9358841730CF}"/>
               </a:ext>
             </a:extLst>
           </p:cNvPr>
@@ -10188,7 +10188,7 @@
           <p:cNvPr id="10" name="">
             <a:extLst xmlns:a="http://schemas.openxmlformats.org/drawingml/2006/main">
               <a:ext uri="{FF2B5EF4-FFF2-40B4-BE49-F238E27FC236}">
-                <a16:creationId xmlns:a16="http://schemas.microsoft.com/office/drawing/2014/main" id="{59BAF4DF-A0CF-4EDE-8B8A-06DD29C7EE97}"/>
+                <a16:creationId xmlns:a16="http://schemas.microsoft.com/office/drawing/2014/main" id="{FFE5ACBF-C51C-4550-8882-2DB116384E01}"/>
               </a:ext>
             </a:extLst>
           </p:cNvPr>
@@ -10346,7 +10346,7 @@
           <p:cNvPr id="11" name="">
             <a:extLst xmlns:a="http://schemas.openxmlformats.org/drawingml/2006/main">
               <a:ext uri="{FF2B5EF4-FFF2-40B4-BE49-F238E27FC236}">
-                <a16:creationId xmlns:a16="http://schemas.microsoft.com/office/drawing/2014/main" id="{613100B1-D1F2-40B5-9B5B-43D9C38C32E4}"/>
+                <a16:creationId xmlns:a16="http://schemas.microsoft.com/office/drawing/2014/main" id="{32378A78-9ECB-4A00-A387-6E59742C11A6}"/>
               </a:ext>
             </a:extLst>
           </p:cNvPr>
@@ -10504,7 +10504,7 @@
           <p:cNvPr id="12" name="">
             <a:extLst xmlns:a="http://schemas.openxmlformats.org/drawingml/2006/main">
               <a:ext uri="{FF2B5EF4-FFF2-40B4-BE49-F238E27FC236}">
-                <a16:creationId xmlns:a16="http://schemas.microsoft.com/office/drawing/2014/main" id="{7E478789-33D4-4DDF-A93F-ABB39145B034}"/>
+                <a16:creationId xmlns:a16="http://schemas.microsoft.com/office/drawing/2014/main" id="{143FC4BE-B095-4427-9C02-0363E45E3952}"/>
               </a:ext>
             </a:extLst>
           </p:cNvPr>
@@ -10660,7 +10660,7 @@
     </p:spTree>
     <p:extLst>
       <p:ext uri="{BB962C8B-B14F-4D97-AF65-F5344CB8AC3E}">
-        <p14:creationId xmlns:p14="http://schemas.microsoft.com/office/powerpoint/2010/main" val="278929053"/>
+        <p14:creationId xmlns:p14="http://schemas.microsoft.com/office/powerpoint/2010/main" val="751527476"/>
       </p:ext>
     </p:extLst>
   </p:cSld>
@@ -10691,7 +10691,7 @@
           <p:cNvPr id="10" name="">
             <a:extLst xmlns:a="http://schemas.openxmlformats.org/drawingml/2006/main">
               <a:ext uri="{FF2B5EF4-FFF2-40B4-BE49-F238E27FC236}">
-                <a16:creationId xmlns:a16="http://schemas.microsoft.com/office/drawing/2014/main" id="{BD9D5444-D7F3-4D58-9A58-744062004371}"/>
+                <a16:creationId xmlns:a16="http://schemas.microsoft.com/office/drawing/2014/main" id="{E1FC4AF1-0995-466D-9759-011D8D75DB2C}"/>
               </a:ext>
             </a:extLst>
           </p:cNvPr>
@@ -10849,7 +10849,7 @@
           <p:cNvPr id="2" name="">
             <a:extLst xmlns:a="http://schemas.openxmlformats.org/drawingml/2006/main">
               <a:ext uri="{FF2B5EF4-FFF2-40B4-BE49-F238E27FC236}">
-                <a16:creationId xmlns:a16="http://schemas.microsoft.com/office/drawing/2014/main" id="{8320F42D-67A4-4FF8-89F3-0C700AB5650F}"/>
+                <a16:creationId xmlns:a16="http://schemas.microsoft.com/office/drawing/2014/main" id="{5B2A3264-C57F-4914-98D8-A4E5FFD1CD44}"/>
               </a:ext>
             </a:extLst>
           </p:cNvPr>
@@ -11007,7 +11007,7 @@
           <p:cNvPr id="3" name="">
             <a:extLst xmlns:a="http://schemas.openxmlformats.org/drawingml/2006/main">
               <a:ext uri="{FF2B5EF4-FFF2-40B4-BE49-F238E27FC236}">
-                <a16:creationId xmlns:a16="http://schemas.microsoft.com/office/drawing/2014/main" id="{92495D79-F2EC-4AB1-B7A6-60B7B4AB19E7}"/>
+                <a16:creationId xmlns:a16="http://schemas.microsoft.com/office/drawing/2014/main" id="{0ED3D607-F96A-481B-B8CB-33C314C275FB}"/>
               </a:ext>
             </a:extLst>
           </p:cNvPr>
@@ -11165,7 +11165,7 @@
           <p:cNvPr id="4" name="">
             <a:extLst xmlns:a="http://schemas.openxmlformats.org/drawingml/2006/main">
               <a:ext uri="{FF2B5EF4-FFF2-40B4-BE49-F238E27FC236}">
-                <a16:creationId xmlns:a16="http://schemas.microsoft.com/office/drawing/2014/main" id="{E9B94647-FCB8-47CA-BCBA-A90ECBE2FA25}"/>
+                <a16:creationId xmlns:a16="http://schemas.microsoft.com/office/drawing/2014/main" id="{ABE65B58-DCC5-4374-8FB5-540A86A5464C}"/>
               </a:ext>
             </a:extLst>
           </p:cNvPr>
@@ -11323,7 +11323,7 @@
           <p:cNvPr id="5" name="">
             <a:extLst xmlns:a="http://schemas.openxmlformats.org/drawingml/2006/main">
               <a:ext uri="{FF2B5EF4-FFF2-40B4-BE49-F238E27FC236}">
-                <a16:creationId xmlns:a16="http://schemas.microsoft.com/office/drawing/2014/main" id="{92E7DAE4-00E7-47BD-9FE6-FE0F466316ED}"/>
+                <a16:creationId xmlns:a16="http://schemas.microsoft.com/office/drawing/2014/main" id="{A3EE2653-16A4-4E4A-8207-4CBB2AD63554}"/>
               </a:ext>
             </a:extLst>
           </p:cNvPr>
@@ -11504,7 +11504,7 @@
           <p:cNvPr id="6" name="">
             <a:extLst xmlns:a="http://schemas.openxmlformats.org/drawingml/2006/main">
               <a:ext uri="{FF2B5EF4-FFF2-40B4-BE49-F238E27FC236}">
-                <a16:creationId xmlns:a16="http://schemas.microsoft.com/office/drawing/2014/main" id="{BD15C0D0-22A8-4180-906C-89F721718D59}"/>
+                <a16:creationId xmlns:a16="http://schemas.microsoft.com/office/drawing/2014/main" id="{E3A5C714-5320-4316-A4B0-409DF4854626}"/>
               </a:ext>
             </a:extLst>
           </p:cNvPr>
@@ -11662,7 +11662,7 @@
           <p:cNvPr id="7" name="">
             <a:extLst xmlns:a="http://schemas.openxmlformats.org/drawingml/2006/main">
               <a:ext uri="{FF2B5EF4-FFF2-40B4-BE49-F238E27FC236}">
-                <a16:creationId xmlns:a16="http://schemas.microsoft.com/office/drawing/2014/main" id="{74D60764-BBBB-4E8A-9987-7979C97A1F90}"/>
+                <a16:creationId xmlns:a16="http://schemas.microsoft.com/office/drawing/2014/main" id="{0049FE02-D672-4E69-8E3F-691A09143F62}"/>
               </a:ext>
             </a:extLst>
           </p:cNvPr>
@@ -11820,7 +11820,7 @@
           <p:cNvPr id="8" name="">
             <a:extLst xmlns:a="http://schemas.openxmlformats.org/drawingml/2006/main">
               <a:ext uri="{FF2B5EF4-FFF2-40B4-BE49-F238E27FC236}">
-                <a16:creationId xmlns:a16="http://schemas.microsoft.com/office/drawing/2014/main" id="{1DCA44EE-F403-4C24-A1E1-EA7061E75E76}"/>
+                <a16:creationId xmlns:a16="http://schemas.microsoft.com/office/drawing/2014/main" id="{46925345-0387-4E2D-8B17-B95032582F1C}"/>
               </a:ext>
             </a:extLst>
           </p:cNvPr>
@@ -11978,7 +11978,7 @@
           <p:cNvPr id="9" name="">
             <a:extLst xmlns:a="http://schemas.openxmlformats.org/drawingml/2006/main">
               <a:ext uri="{FF2B5EF4-FFF2-40B4-BE49-F238E27FC236}">
-                <a16:creationId xmlns:a16="http://schemas.microsoft.com/office/drawing/2014/main" id="{3EFF70EA-590C-4D7B-B886-DA195AF32DB4}"/>
+                <a16:creationId xmlns:a16="http://schemas.microsoft.com/office/drawing/2014/main" id="{A3E58239-763C-40E4-AAEC-F5CD4117A273}"/>
               </a:ext>
             </a:extLst>
           </p:cNvPr>
@@ -12134,7 +12134,7 @@
     </p:spTree>
     <p:extLst>
       <p:ext uri="{BB962C8B-B14F-4D97-AF65-F5344CB8AC3E}">
-        <p14:creationId xmlns:p14="http://schemas.microsoft.com/office/powerpoint/2010/main" val="1801052151"/>
+        <p14:creationId xmlns:p14="http://schemas.microsoft.com/office/powerpoint/2010/main" val="868901533"/>
       </p:ext>
     </p:extLst>
   </p:cSld>
@@ -12165,7 +12165,7 @@
           <p:cNvPr id="12" name="">
             <a:extLst xmlns:a="http://schemas.openxmlformats.org/drawingml/2006/main">
               <a:ext uri="{FF2B5EF4-FFF2-40B4-BE49-F238E27FC236}">
-                <a16:creationId xmlns:a16="http://schemas.microsoft.com/office/drawing/2014/main" id="{2937D4A1-BC3F-4D32-AE1C-052335197920}"/>
+                <a16:creationId xmlns:a16="http://schemas.microsoft.com/office/drawing/2014/main" id="{E6A875D9-9C7D-47DE-A73A-AE43028F7CDE}"/>
               </a:ext>
             </a:extLst>
           </p:cNvPr>
@@ -12323,7 +12323,7 @@
           <p:cNvPr id="2" name="">
             <a:extLst xmlns:a="http://schemas.openxmlformats.org/drawingml/2006/main">
               <a:ext uri="{FF2B5EF4-FFF2-40B4-BE49-F238E27FC236}">
-                <a16:creationId xmlns:a16="http://schemas.microsoft.com/office/drawing/2014/main" id="{D6BCE28F-AD19-4AA5-A99A-83E92FB90221}"/>
+                <a16:creationId xmlns:a16="http://schemas.microsoft.com/office/drawing/2014/main" id="{E6149F24-E291-4AFD-9003-321DB539610B}"/>
               </a:ext>
             </a:extLst>
           </p:cNvPr>
@@ -12481,7 +12481,7 @@
           <p:cNvPr id="3" name="">
             <a:extLst xmlns:a="http://schemas.openxmlformats.org/drawingml/2006/main">
               <a:ext uri="{FF2B5EF4-FFF2-40B4-BE49-F238E27FC236}">
-                <a16:creationId xmlns:a16="http://schemas.microsoft.com/office/drawing/2014/main" id="{0C79C74F-B69C-4855-8CB6-4B43945325E9}"/>
+                <a16:creationId xmlns:a16="http://schemas.microsoft.com/office/drawing/2014/main" id="{EA0AD6B1-783E-4E89-AD48-8F0305645A61}"/>
               </a:ext>
             </a:extLst>
           </p:cNvPr>
@@ -12639,7 +12639,7 @@
           <p:cNvPr id="4" name="">
             <a:extLst xmlns:a="http://schemas.openxmlformats.org/drawingml/2006/main">
               <a:ext uri="{FF2B5EF4-FFF2-40B4-BE49-F238E27FC236}">
-                <a16:creationId xmlns:a16="http://schemas.microsoft.com/office/drawing/2014/main" id="{35798AF7-C1C5-4332-A308-B09711904DA3}"/>
+                <a16:creationId xmlns:a16="http://schemas.microsoft.com/office/drawing/2014/main" id="{095049C9-C97B-43EB-96D0-2BC123DA8A39}"/>
               </a:ext>
             </a:extLst>
           </p:cNvPr>
@@ -12797,7 +12797,7 @@
           <p:cNvPr id="5" name="">
             <a:extLst xmlns:a="http://schemas.openxmlformats.org/drawingml/2006/main">
               <a:ext uri="{FF2B5EF4-FFF2-40B4-BE49-F238E27FC236}">
-                <a16:creationId xmlns:a16="http://schemas.microsoft.com/office/drawing/2014/main" id="{8E61DEB2-40DD-471D-BB3F-56A8DA461FAB}"/>
+                <a16:creationId xmlns:a16="http://schemas.microsoft.com/office/drawing/2014/main" id="{95D4FFE0-DD42-4CC6-AA70-80E93011D8D9}"/>
               </a:ext>
             </a:extLst>
           </p:cNvPr>
@@ -12955,7 +12955,7 @@
           <p:cNvPr id="6" name="">
             <a:extLst xmlns:a="http://schemas.openxmlformats.org/drawingml/2006/main">
               <a:ext uri="{FF2B5EF4-FFF2-40B4-BE49-F238E27FC236}">
-                <a16:creationId xmlns:a16="http://schemas.microsoft.com/office/drawing/2014/main" id="{C72C3228-491F-4847-9FDC-70BB6ABEA54B}"/>
+                <a16:creationId xmlns:a16="http://schemas.microsoft.com/office/drawing/2014/main" id="{1738BAFE-9563-4B86-9C23-E4C82E8CDF72}"/>
               </a:ext>
             </a:extLst>
           </p:cNvPr>
@@ -13136,7 +13136,7 @@
           <p:cNvPr id="7" name="">
             <a:extLst xmlns:a="http://schemas.openxmlformats.org/drawingml/2006/main">
               <a:ext uri="{FF2B5EF4-FFF2-40B4-BE49-F238E27FC236}">
-                <a16:creationId xmlns:a16="http://schemas.microsoft.com/office/drawing/2014/main" id="{4BA77737-1C3D-4EF7-AD30-2D7D217CD382}"/>
+                <a16:creationId xmlns:a16="http://schemas.microsoft.com/office/drawing/2014/main" id="{984DE0D4-1399-427A-884D-6B6A5EBF1906}"/>
               </a:ext>
             </a:extLst>
           </p:cNvPr>
@@ -13294,7 +13294,7 @@
           <p:cNvPr id="8" name="">
             <a:extLst xmlns:a="http://schemas.openxmlformats.org/drawingml/2006/main">
               <a:ext uri="{FF2B5EF4-FFF2-40B4-BE49-F238E27FC236}">
-                <a16:creationId xmlns:a16="http://schemas.microsoft.com/office/drawing/2014/main" id="{A52BFAE7-2470-4E80-931D-6013EA3DCAFC}"/>
+                <a16:creationId xmlns:a16="http://schemas.microsoft.com/office/drawing/2014/main" id="{B3B8F1B1-D7BF-441D-AA1A-7CE75F0FB4EB}"/>
               </a:ext>
             </a:extLst>
           </p:cNvPr>
@@ -13475,7 +13475,7 @@
           <p:cNvPr id="9" name="">
             <a:extLst xmlns:a="http://schemas.openxmlformats.org/drawingml/2006/main">
               <a:ext uri="{FF2B5EF4-FFF2-40B4-BE49-F238E27FC236}">
-                <a16:creationId xmlns:a16="http://schemas.microsoft.com/office/drawing/2014/main" id="{0D0F1DEF-05EB-4373-8403-1634C614F26F}"/>
+                <a16:creationId xmlns:a16="http://schemas.microsoft.com/office/drawing/2014/main" id="{151F1A72-CF7D-43AC-ADEB-9ABEC31866BB}"/>
               </a:ext>
             </a:extLst>
           </p:cNvPr>
@@ -13633,7 +13633,7 @@
           <p:cNvPr id="10" name="">
             <a:extLst xmlns:a="http://schemas.openxmlformats.org/drawingml/2006/main">
               <a:ext uri="{FF2B5EF4-FFF2-40B4-BE49-F238E27FC236}">
-                <a16:creationId xmlns:a16="http://schemas.microsoft.com/office/drawing/2014/main" id="{4F68BE76-8C0C-4DDC-8F20-B03A0145B536}"/>
+                <a16:creationId xmlns:a16="http://schemas.microsoft.com/office/drawing/2014/main" id="{0AA10862-54E5-4594-8978-34EE24B4A2BC}"/>
               </a:ext>
             </a:extLst>
           </p:cNvPr>
@@ -13791,7 +13791,7 @@
           <p:cNvPr id="11" name="">
             <a:extLst xmlns:a="http://schemas.openxmlformats.org/drawingml/2006/main">
               <a:ext uri="{FF2B5EF4-FFF2-40B4-BE49-F238E27FC236}">
-                <a16:creationId xmlns:a16="http://schemas.microsoft.com/office/drawing/2014/main" id="{C3E34CC1-FABC-4FC8-8D50-33ACF68CEED3}"/>
+                <a16:creationId xmlns:a16="http://schemas.microsoft.com/office/drawing/2014/main" id="{1CBE71FE-472A-4FBD-A775-893B683A940C}"/>
               </a:ext>
             </a:extLst>
           </p:cNvPr>
@@ -13947,7 +13947,7 @@
     </p:spTree>
     <p:extLst>
       <p:ext uri="{BB962C8B-B14F-4D97-AF65-F5344CB8AC3E}">
-        <p14:creationId xmlns:p14="http://schemas.microsoft.com/office/powerpoint/2010/main" val="894493440"/>
+        <p14:creationId xmlns:p14="http://schemas.microsoft.com/office/powerpoint/2010/main" val="1897647910"/>
       </p:ext>
     </p:extLst>
   </p:cSld>
@@ -13978,7 +13978,7 @@
           <p:cNvPr id="23" name="">
             <a:extLst xmlns:a="http://schemas.openxmlformats.org/drawingml/2006/main">
               <a:ext uri="{FF2B5EF4-FFF2-40B4-BE49-F238E27FC236}">
-                <a16:creationId xmlns:a16="http://schemas.microsoft.com/office/drawing/2014/main" id="{ACB7B511-E0F5-4C27-AD7C-67552BC0EFFD}"/>
+                <a16:creationId xmlns:a16="http://schemas.microsoft.com/office/drawing/2014/main" id="{7C02E161-538C-4F8E-B605-88AB8A984BC3}"/>
               </a:ext>
             </a:extLst>
           </p:cNvPr>
@@ -14136,7 +14136,7 @@
           <p:cNvPr id="2" name="">
             <a:extLst xmlns:a="http://schemas.openxmlformats.org/drawingml/2006/main">
               <a:ext uri="{FF2B5EF4-FFF2-40B4-BE49-F238E27FC236}">
-                <a16:creationId xmlns:a16="http://schemas.microsoft.com/office/drawing/2014/main" id="{1E494895-A0B0-4870-BE79-7ED7E7535BA3}"/>
+                <a16:creationId xmlns:a16="http://schemas.microsoft.com/office/drawing/2014/main" id="{0F07AD6A-E82B-4C29-9ED9-693EA703CDD5}"/>
               </a:ext>
             </a:extLst>
           </p:cNvPr>
@@ -14294,7 +14294,7 @@
           <p:cNvPr id="3" name="">
             <a:extLst xmlns:a="http://schemas.openxmlformats.org/drawingml/2006/main">
               <a:ext uri="{FF2B5EF4-FFF2-40B4-BE49-F238E27FC236}">
-                <a16:creationId xmlns:a16="http://schemas.microsoft.com/office/drawing/2014/main" id="{9FCE34F3-045D-49EC-A293-117323865F55}"/>
+                <a16:creationId xmlns:a16="http://schemas.microsoft.com/office/drawing/2014/main" id="{A23D311F-60E9-468E-AE24-DEC6DDF5C34E}"/>
               </a:ext>
             </a:extLst>
           </p:cNvPr>
@@ -14452,7 +14452,7 @@
           <p:cNvPr id="4" name="">
             <a:extLst xmlns:a="http://schemas.openxmlformats.org/drawingml/2006/main">
               <a:ext uri="{FF2B5EF4-FFF2-40B4-BE49-F238E27FC236}">
-                <a16:creationId xmlns:a16="http://schemas.microsoft.com/office/drawing/2014/main" id="{97FCB8E5-E2E9-4EED-9A65-6D8C66271554}"/>
+                <a16:creationId xmlns:a16="http://schemas.microsoft.com/office/drawing/2014/main" id="{EA64669D-0D84-4709-93CF-E198FD38F260}"/>
               </a:ext>
             </a:extLst>
           </p:cNvPr>
@@ -14610,7 +14610,7 @@
           <p:cNvPr id="5" name="">
             <a:extLst xmlns:a="http://schemas.openxmlformats.org/drawingml/2006/main">
               <a:ext uri="{FF2B5EF4-FFF2-40B4-BE49-F238E27FC236}">
-                <a16:creationId xmlns:a16="http://schemas.microsoft.com/office/drawing/2014/main" id="{821AA586-1E78-44DA-91D1-480C447D06AE}"/>
+                <a16:creationId xmlns:a16="http://schemas.microsoft.com/office/drawing/2014/main" id="{61D10D0B-A334-4985-AC51-32A1DB161F86}"/>
               </a:ext>
             </a:extLst>
           </p:cNvPr>
@@ -14768,7 +14768,7 @@
           <p:cNvPr id="6" name="">
             <a:extLst xmlns:a="http://schemas.openxmlformats.org/drawingml/2006/main">
               <a:ext uri="{FF2B5EF4-FFF2-40B4-BE49-F238E27FC236}">
-                <a16:creationId xmlns:a16="http://schemas.microsoft.com/office/drawing/2014/main" id="{472C59DF-085C-4F7E-89F9-A1089C762236}"/>
+                <a16:creationId xmlns:a16="http://schemas.microsoft.com/office/drawing/2014/main" id="{5FD88A75-AFB6-47FC-8BF1-FDB0CD08FD65}"/>
               </a:ext>
             </a:extLst>
           </p:cNvPr>
@@ -14926,7 +14926,7 @@
           <p:cNvPr id="7" name="">
             <a:extLst xmlns:a="http://schemas.openxmlformats.org/drawingml/2006/main">
               <a:ext uri="{FF2B5EF4-FFF2-40B4-BE49-F238E27FC236}">
-                <a16:creationId xmlns:a16="http://schemas.microsoft.com/office/drawing/2014/main" id="{7B9B232E-A7EE-4757-A0DC-284A99A6354D}"/>
+                <a16:creationId xmlns:a16="http://schemas.microsoft.com/office/drawing/2014/main" id="{67C7D949-77EF-43B0-89D6-D7EA3928394F}"/>
               </a:ext>
             </a:extLst>
           </p:cNvPr>
@@ -15084,7 +15084,7 @@
           <p:cNvPr id="8" name="">
             <a:extLst xmlns:a="http://schemas.openxmlformats.org/drawingml/2006/main">
               <a:ext uri="{FF2B5EF4-FFF2-40B4-BE49-F238E27FC236}">
-                <a16:creationId xmlns:a16="http://schemas.microsoft.com/office/drawing/2014/main" id="{ECD77EA8-371D-47A4-9DFE-43322684B86F}"/>
+                <a16:creationId xmlns:a16="http://schemas.microsoft.com/office/drawing/2014/main" id="{7A6B372A-7FFA-4B65-B79D-DB4B0C104820}"/>
               </a:ext>
             </a:extLst>
           </p:cNvPr>
@@ -15242,7 +15242,7 @@
           <p:cNvPr id="9" name="">
             <a:extLst xmlns:a="http://schemas.openxmlformats.org/drawingml/2006/main">
               <a:ext uri="{FF2B5EF4-FFF2-40B4-BE49-F238E27FC236}">
-                <a16:creationId xmlns:a16="http://schemas.microsoft.com/office/drawing/2014/main" id="{8A3D54DB-10B2-44F2-83B5-09735AD72963}"/>
+                <a16:creationId xmlns:a16="http://schemas.microsoft.com/office/drawing/2014/main" id="{2DEECE30-8B6F-438B-9CE7-F70C12DA99C5}"/>
               </a:ext>
             </a:extLst>
           </p:cNvPr>
@@ -15400,7 +15400,7 @@
           <p:cNvPr id="10" name="">
             <a:extLst xmlns:a="http://schemas.openxmlformats.org/drawingml/2006/main">
               <a:ext uri="{FF2B5EF4-FFF2-40B4-BE49-F238E27FC236}">
-                <a16:creationId xmlns:a16="http://schemas.microsoft.com/office/drawing/2014/main" id="{78086166-0F13-40CB-AC97-8DBE483D6DCB}"/>
+                <a16:creationId xmlns:a16="http://schemas.microsoft.com/office/drawing/2014/main" id="{90938039-9F7B-49F8-9719-C7DE50305449}"/>
               </a:ext>
             </a:extLst>
           </p:cNvPr>
@@ -15558,7 +15558,7 @@
           <p:cNvPr id="11" name="">
             <a:extLst xmlns:a="http://schemas.openxmlformats.org/drawingml/2006/main">
               <a:ext uri="{FF2B5EF4-FFF2-40B4-BE49-F238E27FC236}">
-                <a16:creationId xmlns:a16="http://schemas.microsoft.com/office/drawing/2014/main" id="{F78D22C0-4873-4406-A2E9-18AC8603DB09}"/>
+                <a16:creationId xmlns:a16="http://schemas.microsoft.com/office/drawing/2014/main" id="{AFACD81A-A293-4FF5-9B94-03168D09AC44}"/>
               </a:ext>
             </a:extLst>
           </p:cNvPr>
@@ -15716,7 +15716,7 @@
           <p:cNvPr id="12" name="">
             <a:extLst xmlns:a="http://schemas.openxmlformats.org/drawingml/2006/main">
               <a:ext uri="{FF2B5EF4-FFF2-40B4-BE49-F238E27FC236}">
-                <a16:creationId xmlns:a16="http://schemas.microsoft.com/office/drawing/2014/main" id="{3A015D9F-7FB4-4DBB-BFD4-14703733C843}"/>
+                <a16:creationId xmlns:a16="http://schemas.microsoft.com/office/drawing/2014/main" id="{938355E8-341E-4300-AB35-A0B6CD672984}"/>
               </a:ext>
             </a:extLst>
           </p:cNvPr>
@@ -15874,7 +15874,7 @@
           <p:cNvPr id="13" name="">
             <a:extLst xmlns:a="http://schemas.openxmlformats.org/drawingml/2006/main">
               <a:ext uri="{FF2B5EF4-FFF2-40B4-BE49-F238E27FC236}">
-                <a16:creationId xmlns:a16="http://schemas.microsoft.com/office/drawing/2014/main" id="{00E4E211-A053-4150-94CD-12983CD576EB}"/>
+                <a16:creationId xmlns:a16="http://schemas.microsoft.com/office/drawing/2014/main" id="{32D2E82B-C653-4A24-A263-CDAD3CC526CB}"/>
               </a:ext>
             </a:extLst>
           </p:cNvPr>
@@ -16032,7 +16032,7 @@
           <p:cNvPr id="14" name="">
             <a:extLst xmlns:a="http://schemas.openxmlformats.org/drawingml/2006/main">
               <a:ext uri="{FF2B5EF4-FFF2-40B4-BE49-F238E27FC236}">
-                <a16:creationId xmlns:a16="http://schemas.microsoft.com/office/drawing/2014/main" id="{A72FA133-99E0-402D-A445-5BB6EE5F41C1}"/>
+                <a16:creationId xmlns:a16="http://schemas.microsoft.com/office/drawing/2014/main" id="{AD2AE04E-90F1-4D54-A736-549FA4749AF6}"/>
               </a:ext>
             </a:extLst>
           </p:cNvPr>
@@ -16190,7 +16190,7 @@
           <p:cNvPr id="15" name="">
             <a:extLst xmlns:a="http://schemas.openxmlformats.org/drawingml/2006/main">
               <a:ext uri="{FF2B5EF4-FFF2-40B4-BE49-F238E27FC236}">
-                <a16:creationId xmlns:a16="http://schemas.microsoft.com/office/drawing/2014/main" id="{B89595E1-3B77-476C-A766-C6A6C25DB825}"/>
+                <a16:creationId xmlns:a16="http://schemas.microsoft.com/office/drawing/2014/main" id="{151C9F5B-9A7A-4BC4-B19E-AFD0D499CA89}"/>
               </a:ext>
             </a:extLst>
           </p:cNvPr>
@@ -16348,7 +16348,7 @@
           <p:cNvPr id="16" name="">
             <a:extLst xmlns:a="http://schemas.openxmlformats.org/drawingml/2006/main">
               <a:ext uri="{FF2B5EF4-FFF2-40B4-BE49-F238E27FC236}">
-                <a16:creationId xmlns:a16="http://schemas.microsoft.com/office/drawing/2014/main" id="{12AE334D-39A4-4D22-8A45-41C047882369}"/>
+                <a16:creationId xmlns:a16="http://schemas.microsoft.com/office/drawing/2014/main" id="{D4E3BF40-4EF9-4C4A-9D23-DFFD6D79D7B0}"/>
               </a:ext>
             </a:extLst>
           </p:cNvPr>
@@ -16506,7 +16506,7 @@
           <p:cNvPr id="17" name="">
             <a:extLst xmlns:a="http://schemas.openxmlformats.org/drawingml/2006/main">
               <a:ext uri="{FF2B5EF4-FFF2-40B4-BE49-F238E27FC236}">
-                <a16:creationId xmlns:a16="http://schemas.microsoft.com/office/drawing/2014/main" id="{8D5079D9-D244-41E4-91C1-6435E3A2D0C3}"/>
+                <a16:creationId xmlns:a16="http://schemas.microsoft.com/office/drawing/2014/main" id="{BC497032-FAA2-466E-92BD-5150C906BDE7}"/>
               </a:ext>
             </a:extLst>
           </p:cNvPr>
@@ -16664,7 +16664,7 @@
           <p:cNvPr id="18" name="">
             <a:extLst xmlns:a="http://schemas.openxmlformats.org/drawingml/2006/main">
               <a:ext uri="{FF2B5EF4-FFF2-40B4-BE49-F238E27FC236}">
-                <a16:creationId xmlns:a16="http://schemas.microsoft.com/office/drawing/2014/main" id="{D5BAC673-4FF3-4C11-BFD8-F146EFAB8383}"/>
+                <a16:creationId xmlns:a16="http://schemas.microsoft.com/office/drawing/2014/main" id="{B0F91B05-4C57-4A03-A950-993A0CE4BF22}"/>
               </a:ext>
             </a:extLst>
           </p:cNvPr>
@@ -16822,7 +16822,7 @@
           <p:cNvPr id="19" name="">
             <a:extLst xmlns:a="http://schemas.openxmlformats.org/drawingml/2006/main">
               <a:ext uri="{FF2B5EF4-FFF2-40B4-BE49-F238E27FC236}">
-                <a16:creationId xmlns:a16="http://schemas.microsoft.com/office/drawing/2014/main" id="{A601E45D-A5D7-48B3-B98E-EBEFFE1EFC00}"/>
+                <a16:creationId xmlns:a16="http://schemas.microsoft.com/office/drawing/2014/main" id="{EAB821D9-6F34-472A-95E8-A7A6A21D8F87}"/>
               </a:ext>
             </a:extLst>
           </p:cNvPr>
@@ -16980,7 +16980,7 @@
           <p:cNvPr id="20" name="">
             <a:extLst xmlns:a="http://schemas.openxmlformats.org/drawingml/2006/main">
               <a:ext uri="{FF2B5EF4-FFF2-40B4-BE49-F238E27FC236}">
-                <a16:creationId xmlns:a16="http://schemas.microsoft.com/office/drawing/2014/main" id="{E8F916C4-3650-4FCF-89DF-42A602737D83}"/>
+                <a16:creationId xmlns:a16="http://schemas.microsoft.com/office/drawing/2014/main" id="{D97B1154-98EF-4FC6-A84B-B20E52890C47}"/>
               </a:ext>
             </a:extLst>
           </p:cNvPr>
@@ -17138,7 +17138,7 @@
           <p:cNvPr id="21" name="">
             <a:extLst xmlns:a="http://schemas.openxmlformats.org/drawingml/2006/main">
               <a:ext uri="{FF2B5EF4-FFF2-40B4-BE49-F238E27FC236}">
-                <a16:creationId xmlns:a16="http://schemas.microsoft.com/office/drawing/2014/main" id="{C87389A3-5513-43D0-92EA-713223CBA103}"/>
+                <a16:creationId xmlns:a16="http://schemas.microsoft.com/office/drawing/2014/main" id="{09EFD7A1-4CB8-4923-B4BA-173F8FD44A45}"/>
               </a:ext>
             </a:extLst>
           </p:cNvPr>
@@ -17296,7 +17296,7 @@
           <p:cNvPr id="22" name="">
             <a:extLst xmlns:a="http://schemas.openxmlformats.org/drawingml/2006/main">
               <a:ext uri="{FF2B5EF4-FFF2-40B4-BE49-F238E27FC236}">
-                <a16:creationId xmlns:a16="http://schemas.microsoft.com/office/drawing/2014/main" id="{1C8A3A63-4503-4189-A971-97CAD9E65A9A}"/>
+                <a16:creationId xmlns:a16="http://schemas.microsoft.com/office/drawing/2014/main" id="{709FC0DC-32B8-4B24-BEF0-37994968FFA5}"/>
               </a:ext>
             </a:extLst>
           </p:cNvPr>
@@ -17452,7 +17452,7 @@
     </p:spTree>
     <p:extLst>
       <p:ext uri="{BB962C8B-B14F-4D97-AF65-F5344CB8AC3E}">
-        <p14:creationId xmlns:p14="http://schemas.microsoft.com/office/powerpoint/2010/main" val="938597331"/>
+        <p14:creationId xmlns:p14="http://schemas.microsoft.com/office/powerpoint/2010/main" val="1755703636"/>
       </p:ext>
     </p:extLst>
   </p:cSld>
@@ -17483,7 +17483,7 @@
           <p:cNvPr id="9" name="">
             <a:extLst xmlns:a="http://schemas.openxmlformats.org/drawingml/2006/main">
               <a:ext uri="{FF2B5EF4-FFF2-40B4-BE49-F238E27FC236}">
-                <a16:creationId xmlns:a16="http://schemas.microsoft.com/office/drawing/2014/main" id="{E98F9318-7DE1-49EA-B4E4-D86137768D8C}"/>
+                <a16:creationId xmlns:a16="http://schemas.microsoft.com/office/drawing/2014/main" id="{565547DF-DAC1-4F8B-9A4D-AC260A061944}"/>
               </a:ext>
             </a:extLst>
           </p:cNvPr>
@@ -17641,7 +17641,7 @@
           <p:cNvPr id="2" name="">
             <a:extLst xmlns:a="http://schemas.openxmlformats.org/drawingml/2006/main">
               <a:ext uri="{FF2B5EF4-FFF2-40B4-BE49-F238E27FC236}">
-                <a16:creationId xmlns:a16="http://schemas.microsoft.com/office/drawing/2014/main" id="{9A70D443-390B-4F5D-801A-38EA5B6C04CA}"/>
+                <a16:creationId xmlns:a16="http://schemas.microsoft.com/office/drawing/2014/main" id="{C338D6F9-5310-439C-AB15-132E7C3BAFD7}"/>
               </a:ext>
             </a:extLst>
           </p:cNvPr>
@@ -17799,7 +17799,7 @@
           <p:cNvPr id="3" name="">
             <a:extLst xmlns:a="http://schemas.openxmlformats.org/drawingml/2006/main">
               <a:ext uri="{FF2B5EF4-FFF2-40B4-BE49-F238E27FC236}">
-                <a16:creationId xmlns:a16="http://schemas.microsoft.com/office/drawing/2014/main" id="{9EACEA94-72E0-4E47-A9FE-4429ACE9F0DF}"/>
+                <a16:creationId xmlns:a16="http://schemas.microsoft.com/office/drawing/2014/main" id="{B65520B4-923D-4C19-AC30-535A1569FA82}"/>
               </a:ext>
             </a:extLst>
           </p:cNvPr>
@@ -17957,7 +17957,7 @@
           <p:cNvPr id="4" name="">
             <a:extLst xmlns:a="http://schemas.openxmlformats.org/drawingml/2006/main">
               <a:ext uri="{FF2B5EF4-FFF2-40B4-BE49-F238E27FC236}">
-                <a16:creationId xmlns:a16="http://schemas.microsoft.com/office/drawing/2014/main" id="{1F5C0B6C-C3BE-4B4B-834C-3ACDBCEF7C38}"/>
+                <a16:creationId xmlns:a16="http://schemas.microsoft.com/office/drawing/2014/main" id="{B596B1D1-E3C4-4355-A8FD-499A83AB6122}"/>
               </a:ext>
             </a:extLst>
           </p:cNvPr>
@@ -18115,7 +18115,7 @@
           <p:cNvPr id="5" name="">
             <a:extLst xmlns:a="http://schemas.openxmlformats.org/drawingml/2006/main">
               <a:ext uri="{FF2B5EF4-FFF2-40B4-BE49-F238E27FC236}">
-                <a16:creationId xmlns:a16="http://schemas.microsoft.com/office/drawing/2014/main" id="{9F5EE6C9-2049-4875-9330-96CE50A6BE5E}"/>
+                <a16:creationId xmlns:a16="http://schemas.microsoft.com/office/drawing/2014/main" id="{E686779F-EC45-4F8D-A771-C35EEDB1C8F7}"/>
               </a:ext>
             </a:extLst>
           </p:cNvPr>
@@ -18125,7 +18125,7 @@
           <p:nvPr/>
         </p:nvPicPr>
         <p:blipFill>
-          <a:blip xmlns:r="http://schemas.openxmlformats.org/officeDocument/2006/relationships" xmlns:a="http://schemas.openxmlformats.org/drawingml/2006/main" r:embed="Reb62e0667143433a"/>
+          <a:blip xmlns:r="http://schemas.openxmlformats.org/officeDocument/2006/relationships" xmlns:a="http://schemas.openxmlformats.org/drawingml/2006/main" r:embed="R9a9837fbf3464e52"/>
           <a:stretch xmlns:a="http://schemas.openxmlformats.org/drawingml/2006/main"/>
         </p:blipFill>
         <p:spPr>
@@ -18143,7 +18143,7 @@
           <p:cNvPr id="6" name="">
             <a:extLst xmlns:a="http://schemas.openxmlformats.org/drawingml/2006/main">
               <a:ext uri="{FF2B5EF4-FFF2-40B4-BE49-F238E27FC236}">
-                <a16:creationId xmlns:a16="http://schemas.microsoft.com/office/drawing/2014/main" id="{F00FDA3C-E53C-441D-B8B6-9E6BCAEA922B}"/>
+                <a16:creationId xmlns:a16="http://schemas.microsoft.com/office/drawing/2014/main" id="{40467B9F-A520-4AAC-B6FC-95BF6A0F1377}"/>
               </a:ext>
             </a:extLst>
           </p:cNvPr>
@@ -18370,7 +18370,7 @@
           <p:cNvPr id="7" name="">
             <a:extLst xmlns:a="http://schemas.openxmlformats.org/drawingml/2006/main">
               <a:ext uri="{FF2B5EF4-FFF2-40B4-BE49-F238E27FC236}">
-                <a16:creationId xmlns:a16="http://schemas.microsoft.com/office/drawing/2014/main" id="{B701C47D-1AA0-48DF-A6EA-B3326B8CC58F}"/>
+                <a16:creationId xmlns:a16="http://schemas.microsoft.com/office/drawing/2014/main" id="{2B898833-D070-4B31-8A4F-E1D381C1808B}"/>
               </a:ext>
             </a:extLst>
           </p:cNvPr>
@@ -18574,7 +18574,7 @@
           <p:cNvPr id="8" name="">
             <a:extLst xmlns:a="http://schemas.openxmlformats.org/drawingml/2006/main">
               <a:ext uri="{FF2B5EF4-FFF2-40B4-BE49-F238E27FC236}">
-                <a16:creationId xmlns:a16="http://schemas.microsoft.com/office/drawing/2014/main" id="{C0971291-9FE4-42F8-9012-E77F4950377C}"/>
+                <a16:creationId xmlns:a16="http://schemas.microsoft.com/office/drawing/2014/main" id="{047F4C70-C328-475B-9A84-19D08CD1195F}"/>
               </a:ext>
             </a:extLst>
           </p:cNvPr>
@@ -18730,7 +18730,7 @@
     </p:spTree>
     <p:extLst>
       <p:ext uri="{BB962C8B-B14F-4D97-AF65-F5344CB8AC3E}">
-        <p14:creationId xmlns:p14="http://schemas.microsoft.com/office/powerpoint/2010/main" val="511485241"/>
+        <p14:creationId xmlns:p14="http://schemas.microsoft.com/office/powerpoint/2010/main" val="1500824960"/>
       </p:ext>
     </p:extLst>
   </p:cSld>
@@ -18761,7 +18761,7 @@
           <p:cNvPr id="11" name="">
             <a:extLst xmlns:a="http://schemas.openxmlformats.org/drawingml/2006/main">
               <a:ext uri="{FF2B5EF4-FFF2-40B4-BE49-F238E27FC236}">
-                <a16:creationId xmlns:a16="http://schemas.microsoft.com/office/drawing/2014/main" id="{E6333CB5-8A81-4747-88E5-29C8CC3441D1}"/>
+                <a16:creationId xmlns:a16="http://schemas.microsoft.com/office/drawing/2014/main" id="{6EA9BB79-8884-4337-B81C-67944FCC0320}"/>
               </a:ext>
             </a:extLst>
           </p:cNvPr>
@@ -18919,7 +18919,7 @@
           <p:cNvPr id="2" name="">
             <a:extLst xmlns:a="http://schemas.openxmlformats.org/drawingml/2006/main">
               <a:ext uri="{FF2B5EF4-FFF2-40B4-BE49-F238E27FC236}">
-                <a16:creationId xmlns:a16="http://schemas.microsoft.com/office/drawing/2014/main" id="{0563AA5B-6491-48AD-B37E-63410C523EA5}"/>
+                <a16:creationId xmlns:a16="http://schemas.microsoft.com/office/drawing/2014/main" id="{321D8E7B-239C-466F-8291-29FA88C37D30}"/>
               </a:ext>
             </a:extLst>
           </p:cNvPr>
@@ -19077,7 +19077,7 @@
           <p:cNvPr id="3" name="">
             <a:extLst xmlns:a="http://schemas.openxmlformats.org/drawingml/2006/main">
               <a:ext uri="{FF2B5EF4-FFF2-40B4-BE49-F238E27FC236}">
-                <a16:creationId xmlns:a16="http://schemas.microsoft.com/office/drawing/2014/main" id="{887776C8-1A51-471B-B835-3339D7ECC739}"/>
+                <a16:creationId xmlns:a16="http://schemas.microsoft.com/office/drawing/2014/main" id="{E7CA727A-341F-4283-A6E5-6FCF65924631}"/>
               </a:ext>
             </a:extLst>
           </p:cNvPr>
@@ -19235,7 +19235,7 @@
           <p:cNvPr id="4" name="">
             <a:extLst xmlns:a="http://schemas.openxmlformats.org/drawingml/2006/main">
               <a:ext uri="{FF2B5EF4-FFF2-40B4-BE49-F238E27FC236}">
-                <a16:creationId xmlns:a16="http://schemas.microsoft.com/office/drawing/2014/main" id="{88CD110A-EB4E-4B88-BA3F-495B2B5A5DA4}"/>
+                <a16:creationId xmlns:a16="http://schemas.microsoft.com/office/drawing/2014/main" id="{5BD5F89B-2B3E-422B-AA8A-8B8190C5DB11}"/>
               </a:ext>
             </a:extLst>
           </p:cNvPr>
@@ -19393,7 +19393,7 @@
           <p:cNvPr id="5" name="Chart">
             <a:extLst xmlns:a="http://schemas.openxmlformats.org/drawingml/2006/main">
               <a:ext uri="{FF2B5EF4-FFF2-40B4-BE49-F238E27FC236}">
-                <a16:creationId xmlns:a16="http://schemas.microsoft.com/office/drawing/2014/main" id="{D1C16A0B-EE50-40C1-9CC5-65D0E8294F88}"/>
+                <a16:creationId xmlns:a16="http://schemas.microsoft.com/office/drawing/2014/main" id="{56234934-626B-421C-AC58-9EB894615826}"/>
               </a:ext>
             </a:extLst>
           </p:cNvPr>
@@ -19406,7 +19406,7 @@
         </p:xfrm>
         <a:graphic xmlns:a="http://schemas.openxmlformats.org/drawingml/2006/main">
           <a:graphicData uri="http://schemas.openxmlformats.org/drawingml/2006/chart">
-            <c:chart xmlns:r="http://schemas.openxmlformats.org/officeDocument/2006/relationships" xmlns:c="http://schemas.openxmlformats.org/drawingml/2006/chart" r:id="Rc20e07bf74994c50"/>
+            <c:chart xmlns:r="http://schemas.openxmlformats.org/officeDocument/2006/relationships" xmlns:c="http://schemas.openxmlformats.org/drawingml/2006/chart" r:id="R23fc3a36b6fa49ae"/>
           </a:graphicData>
         </a:graphic>
       </p:graphicFrame>
@@ -19415,7 +19415,7 @@
           <p:cNvPr id="6" name="">
             <a:extLst xmlns:a="http://schemas.openxmlformats.org/drawingml/2006/main">
               <a:ext uri="{FF2B5EF4-FFF2-40B4-BE49-F238E27FC236}">
-                <a16:creationId xmlns:a16="http://schemas.microsoft.com/office/drawing/2014/main" id="{A4C339D9-E6D1-4690-B72D-4FCC1BD8F067}"/>
+                <a16:creationId xmlns:a16="http://schemas.microsoft.com/office/drawing/2014/main" id="{66CD25CF-ACFA-4DDC-B46D-295F2319275C}"/>
               </a:ext>
             </a:extLst>
           </p:cNvPr>
@@ -19425,7 +19425,7 @@
           <p:nvPr/>
         </p:nvPicPr>
         <p:blipFill>
-          <a:blip xmlns:r="http://schemas.openxmlformats.org/officeDocument/2006/relationships" xmlns:a="http://schemas.openxmlformats.org/drawingml/2006/main" r:embed="Rc0c0fcacacc14759"/>
+          <a:blip xmlns:r="http://schemas.openxmlformats.org/officeDocument/2006/relationships" xmlns:a="http://schemas.openxmlformats.org/drawingml/2006/main" r:embed="R7c30fc94504e4524"/>
           <a:stretch xmlns:a="http://schemas.openxmlformats.org/drawingml/2006/main"/>
         </p:blipFill>
         <p:spPr>
@@ -19443,7 +19443,7 @@
           <p:cNvPr id="7" name="">
             <a:extLst xmlns:a="http://schemas.openxmlformats.org/drawingml/2006/main">
               <a:ext uri="{FF2B5EF4-FFF2-40B4-BE49-F238E27FC236}">
-                <a16:creationId xmlns:a16="http://schemas.microsoft.com/office/drawing/2014/main" id="{14EC5328-5B66-4D72-A350-1219FC6CE15D}"/>
+                <a16:creationId xmlns:a16="http://schemas.microsoft.com/office/drawing/2014/main" id="{98020DD1-E8AB-42BD-900F-CB1DC74DC4B5}"/>
               </a:ext>
             </a:extLst>
           </p:cNvPr>
@@ -19624,7 +19624,7 @@
           <p:cNvPr id="8" name="">
             <a:extLst xmlns:a="http://schemas.openxmlformats.org/drawingml/2006/main">
               <a:ext uri="{FF2B5EF4-FFF2-40B4-BE49-F238E27FC236}">
-                <a16:creationId xmlns:a16="http://schemas.microsoft.com/office/drawing/2014/main" id="{B1E29FC2-5D98-45BF-AD2C-0BF3F5D1CA04}"/>
+                <a16:creationId xmlns:a16="http://schemas.microsoft.com/office/drawing/2014/main" id="{900C559D-0B1F-4ADA-9DB0-B2D7C1F58684}"/>
               </a:ext>
             </a:extLst>
           </p:cNvPr>
@@ -19782,7 +19782,7 @@
           <p:cNvPr id="9" name="">
             <a:extLst xmlns:a="http://schemas.openxmlformats.org/drawingml/2006/main">
               <a:ext uri="{FF2B5EF4-FFF2-40B4-BE49-F238E27FC236}">
-                <a16:creationId xmlns:a16="http://schemas.microsoft.com/office/drawing/2014/main" id="{0481549F-A959-486D-B57F-3600C1A49104}"/>
+                <a16:creationId xmlns:a16="http://schemas.microsoft.com/office/drawing/2014/main" id="{98103813-B239-4AE6-A8E7-2228F91D6AAF}"/>
               </a:ext>
             </a:extLst>
           </p:cNvPr>
@@ -19940,7 +19940,7 @@
           <p:cNvPr id="10" name="">
             <a:extLst xmlns:a="http://schemas.openxmlformats.org/drawingml/2006/main">
               <a:ext uri="{FF2B5EF4-FFF2-40B4-BE49-F238E27FC236}">
-                <a16:creationId xmlns:a16="http://schemas.microsoft.com/office/drawing/2014/main" id="{73946303-3209-4CCE-80B1-562B424915A2}"/>
+                <a16:creationId xmlns:a16="http://schemas.microsoft.com/office/drawing/2014/main" id="{C48110F4-8617-4F73-BF09-7F6ACC1FE66B}"/>
               </a:ext>
             </a:extLst>
           </p:cNvPr>
@@ -20096,7 +20096,7 @@
     </p:spTree>
     <p:extLst>
       <p:ext uri="{BB962C8B-B14F-4D97-AF65-F5344CB8AC3E}">
-        <p14:creationId xmlns:p14="http://schemas.microsoft.com/office/powerpoint/2010/main" val="1227948224"/>
+        <p14:creationId xmlns:p14="http://schemas.microsoft.com/office/powerpoint/2010/main" val="1571966168"/>
       </p:ext>
     </p:extLst>
   </p:cSld>
@@ -20127,7 +20127,7 @@
           <p:cNvPr id="13" name="">
             <a:extLst xmlns:a="http://schemas.openxmlformats.org/drawingml/2006/main">
               <a:ext uri="{FF2B5EF4-FFF2-40B4-BE49-F238E27FC236}">
-                <a16:creationId xmlns:a16="http://schemas.microsoft.com/office/drawing/2014/main" id="{2E06575B-C3A3-4722-BA1D-F693752D8316}"/>
+                <a16:creationId xmlns:a16="http://schemas.microsoft.com/office/drawing/2014/main" id="{C7B1868E-0638-48C2-8055-D3FD0074BC87}"/>
               </a:ext>
             </a:extLst>
           </p:cNvPr>
@@ -20285,7 +20285,7 @@
           <p:cNvPr id="2" name="">
             <a:extLst xmlns:a="http://schemas.openxmlformats.org/drawingml/2006/main">
               <a:ext uri="{FF2B5EF4-FFF2-40B4-BE49-F238E27FC236}">
-                <a16:creationId xmlns:a16="http://schemas.microsoft.com/office/drawing/2014/main" id="{6AF1EB9A-10F2-409D-83FC-BDC96FD34F80}"/>
+                <a16:creationId xmlns:a16="http://schemas.microsoft.com/office/drawing/2014/main" id="{9BD0FECA-EF02-4A1C-824C-78DF51D7637E}"/>
               </a:ext>
             </a:extLst>
           </p:cNvPr>
@@ -20443,7 +20443,7 @@
           <p:cNvPr id="3" name="">
             <a:extLst xmlns:a="http://schemas.openxmlformats.org/drawingml/2006/main">
               <a:ext uri="{FF2B5EF4-FFF2-40B4-BE49-F238E27FC236}">
-                <a16:creationId xmlns:a16="http://schemas.microsoft.com/office/drawing/2014/main" id="{B4BCF30A-22B7-4C14-B724-82CC7453DD1E}"/>
+                <a16:creationId xmlns:a16="http://schemas.microsoft.com/office/drawing/2014/main" id="{D2112D42-800C-4900-832F-10362EEDC877}"/>
               </a:ext>
             </a:extLst>
           </p:cNvPr>
@@ -20601,7 +20601,7 @@
           <p:cNvPr id="4" name="">
             <a:extLst xmlns:a="http://schemas.openxmlformats.org/drawingml/2006/main">
               <a:ext uri="{FF2B5EF4-FFF2-40B4-BE49-F238E27FC236}">
-                <a16:creationId xmlns:a16="http://schemas.microsoft.com/office/drawing/2014/main" id="{7BDAF500-159E-42BE-B053-54AE80A63F86}"/>
+                <a16:creationId xmlns:a16="http://schemas.microsoft.com/office/drawing/2014/main" id="{D1F73906-F509-40CA-9440-9305C1CEE42A}"/>
               </a:ext>
             </a:extLst>
           </p:cNvPr>
@@ -20759,7 +20759,7 @@
           <p:cNvPr id="5" name="">
             <a:extLst xmlns:a="http://schemas.openxmlformats.org/drawingml/2006/main">
               <a:ext uri="{FF2B5EF4-FFF2-40B4-BE49-F238E27FC236}">
-                <a16:creationId xmlns:a16="http://schemas.microsoft.com/office/drawing/2014/main" id="{C9F38A6C-B6A0-4977-8AEC-563E1FA3E1CC}"/>
+                <a16:creationId xmlns:a16="http://schemas.microsoft.com/office/drawing/2014/main" id="{BAA5656C-9FDE-439A-BEEA-FC68FAD36427}"/>
               </a:ext>
             </a:extLst>
           </p:cNvPr>
@@ -20917,7 +20917,7 @@
           <p:cNvPr id="6" name="">
             <a:extLst xmlns:a="http://schemas.openxmlformats.org/drawingml/2006/main">
               <a:ext uri="{FF2B5EF4-FFF2-40B4-BE49-F238E27FC236}">
-                <a16:creationId xmlns:a16="http://schemas.microsoft.com/office/drawing/2014/main" id="{ECFE5879-72AD-49C4-B646-F808E990ED4C}"/>
+                <a16:creationId xmlns:a16="http://schemas.microsoft.com/office/drawing/2014/main" id="{E4198A87-51BF-42CC-B961-E8F109CA6697}"/>
               </a:ext>
             </a:extLst>
           </p:cNvPr>
@@ -21075,7 +21075,7 @@
           <p:cNvPr id="7" name="">
             <a:extLst xmlns:a="http://schemas.openxmlformats.org/drawingml/2006/main">
               <a:ext uri="{FF2B5EF4-FFF2-40B4-BE49-F238E27FC236}">
-                <a16:creationId xmlns:a16="http://schemas.microsoft.com/office/drawing/2014/main" id="{B582E57F-8155-41C4-A407-5E4B4CD90568}"/>
+                <a16:creationId xmlns:a16="http://schemas.microsoft.com/office/drawing/2014/main" id="{7B625BA9-93AD-4658-886E-A464324FA891}"/>
               </a:ext>
             </a:extLst>
           </p:cNvPr>
@@ -21233,7 +21233,7 @@
           <p:cNvPr id="8" name="">
             <a:extLst xmlns:a="http://schemas.openxmlformats.org/drawingml/2006/main">
               <a:ext uri="{FF2B5EF4-FFF2-40B4-BE49-F238E27FC236}">
-                <a16:creationId xmlns:a16="http://schemas.microsoft.com/office/drawing/2014/main" id="{BD318A38-BBA7-41F7-B1E5-4661B1B842BD}"/>
+                <a16:creationId xmlns:a16="http://schemas.microsoft.com/office/drawing/2014/main" id="{B59C4ECE-7231-4C22-9CD3-BAE026889A4C}"/>
               </a:ext>
             </a:extLst>
           </p:cNvPr>
@@ -21391,7 +21391,7 @@
           <p:cNvPr id="9" name="">
             <a:extLst xmlns:a="http://schemas.openxmlformats.org/drawingml/2006/main">
               <a:ext uri="{FF2B5EF4-FFF2-40B4-BE49-F238E27FC236}">
-                <a16:creationId xmlns:a16="http://schemas.microsoft.com/office/drawing/2014/main" id="{AD19C0EC-ED77-4558-A26C-7BDC9CD9B8FF}"/>
+                <a16:creationId xmlns:a16="http://schemas.microsoft.com/office/drawing/2014/main" id="{A0EEE691-7737-4F84-8621-D57BCFA73000}"/>
               </a:ext>
             </a:extLst>
           </p:cNvPr>
@@ -21549,7 +21549,7 @@
           <p:cNvPr id="10" name="">
             <a:extLst xmlns:a="http://schemas.openxmlformats.org/drawingml/2006/main">
               <a:ext uri="{FF2B5EF4-FFF2-40B4-BE49-F238E27FC236}">
-                <a16:creationId xmlns:a16="http://schemas.microsoft.com/office/drawing/2014/main" id="{BA04CDB4-9636-4B41-A0F1-A4FCEC7F8B81}"/>
+                <a16:creationId xmlns:a16="http://schemas.microsoft.com/office/drawing/2014/main" id="{5862E57B-0BDA-4539-BBF3-86FC2B2CB3AC}"/>
               </a:ext>
             </a:extLst>
           </p:cNvPr>
@@ -21707,7 +21707,7 @@
           <p:cNvPr id="11" name="">
             <a:extLst xmlns:a="http://schemas.openxmlformats.org/drawingml/2006/main">
               <a:ext uri="{FF2B5EF4-FFF2-40B4-BE49-F238E27FC236}">
-                <a16:creationId xmlns:a16="http://schemas.microsoft.com/office/drawing/2014/main" id="{3799FAA3-21CE-4FDC-90FB-8507C7F879CE}"/>
+                <a16:creationId xmlns:a16="http://schemas.microsoft.com/office/drawing/2014/main" id="{AD0C5458-5D3E-486E-AED0-1508CCB6D645}"/>
               </a:ext>
             </a:extLst>
           </p:cNvPr>
@@ -21865,7 +21865,7 @@
           <p:cNvPr id="12" name="">
             <a:extLst xmlns:a="http://schemas.openxmlformats.org/drawingml/2006/main">
               <a:ext uri="{FF2B5EF4-FFF2-40B4-BE49-F238E27FC236}">
-                <a16:creationId xmlns:a16="http://schemas.microsoft.com/office/drawing/2014/main" id="{EEDBAA5C-D918-4775-ACBB-419CD122F3FE}"/>
+                <a16:creationId xmlns:a16="http://schemas.microsoft.com/office/drawing/2014/main" id="{4DBC2D49-EB9F-4D58-BB1E-D22B2F9DD2D8}"/>
               </a:ext>
             </a:extLst>
           </p:cNvPr>
@@ -22021,7 +22021,7 @@
     </p:spTree>
     <p:extLst>
       <p:ext uri="{BB962C8B-B14F-4D97-AF65-F5344CB8AC3E}">
-        <p14:creationId xmlns:p14="http://schemas.microsoft.com/office/powerpoint/2010/main" val="1517390617"/>
+        <p14:creationId xmlns:p14="http://schemas.microsoft.com/office/powerpoint/2010/main" val="312622636"/>
       </p:ext>
     </p:extLst>
   </p:cSld>
@@ -22052,7 +22052,7 @@
           <p:cNvPr id="8" name="">
             <a:extLst xmlns:a="http://schemas.openxmlformats.org/drawingml/2006/main">
               <a:ext uri="{FF2B5EF4-FFF2-40B4-BE49-F238E27FC236}">
-                <a16:creationId xmlns:a16="http://schemas.microsoft.com/office/drawing/2014/main" id="{C77B6714-E3C9-4706-A8F8-B477AC3D155E}"/>
+                <a16:creationId xmlns:a16="http://schemas.microsoft.com/office/drawing/2014/main" id="{AF1FAA19-5C73-40B2-8797-031169EA54BB}"/>
               </a:ext>
             </a:extLst>
           </p:cNvPr>
@@ -22210,7 +22210,7 @@
           <p:cNvPr id="2" name="">
             <a:extLst xmlns:a="http://schemas.openxmlformats.org/drawingml/2006/main">
               <a:ext uri="{FF2B5EF4-FFF2-40B4-BE49-F238E27FC236}">
-                <a16:creationId xmlns:a16="http://schemas.microsoft.com/office/drawing/2014/main" id="{B1B7D358-91D5-4ADB-8797-36B5D17C3274}"/>
+                <a16:creationId xmlns:a16="http://schemas.microsoft.com/office/drawing/2014/main" id="{02FDD926-2D89-453B-B17E-3C23589F7EEB}"/>
               </a:ext>
             </a:extLst>
           </p:cNvPr>
@@ -22368,7 +22368,7 @@
           <p:cNvPr id="3" name="">
             <a:extLst xmlns:a="http://schemas.openxmlformats.org/drawingml/2006/main">
               <a:ext uri="{FF2B5EF4-FFF2-40B4-BE49-F238E27FC236}">
-                <a16:creationId xmlns:a16="http://schemas.microsoft.com/office/drawing/2014/main" id="{D61988A2-473B-4131-B798-22DFFA3646B4}"/>
+                <a16:creationId xmlns:a16="http://schemas.microsoft.com/office/drawing/2014/main" id="{83EC896C-3BAE-4D51-AFBD-EC7BA5BAB640}"/>
               </a:ext>
             </a:extLst>
           </p:cNvPr>
@@ -22526,7 +22526,7 @@
           <p:cNvPr id="4" name="">
             <a:extLst xmlns:a="http://schemas.openxmlformats.org/drawingml/2006/main">
               <a:ext uri="{FF2B5EF4-FFF2-40B4-BE49-F238E27FC236}">
-                <a16:creationId xmlns:a16="http://schemas.microsoft.com/office/drawing/2014/main" id="{F49A9850-34E3-4467-81E9-19B1FEB400C1}"/>
+                <a16:creationId xmlns:a16="http://schemas.microsoft.com/office/drawing/2014/main" id="{5093CAD3-85D8-4879-8337-2FB90191E9C3}"/>
               </a:ext>
             </a:extLst>
           </p:cNvPr>
@@ -22684,7 +22684,7 @@
           <p:cNvPr id="5" name="">
             <a:extLst xmlns:a="http://schemas.openxmlformats.org/drawingml/2006/main">
               <a:ext uri="{FF2B5EF4-FFF2-40B4-BE49-F238E27FC236}">
-                <a16:creationId xmlns:a16="http://schemas.microsoft.com/office/drawing/2014/main" id="{AE81D33A-17D0-4050-BADD-155D90ADBC6B}"/>
+                <a16:creationId xmlns:a16="http://schemas.microsoft.com/office/drawing/2014/main" id="{78C51F57-D90E-45CF-A793-7D6D9D44ECEF}"/>
               </a:ext>
             </a:extLst>
           </p:cNvPr>
@@ -23131,7 +23131,7 @@
           <p:cNvPr id="6" name="">
             <a:extLst xmlns:a="http://schemas.openxmlformats.org/drawingml/2006/main">
               <a:ext uri="{FF2B5EF4-FFF2-40B4-BE49-F238E27FC236}">
-                <a16:creationId xmlns:a16="http://schemas.microsoft.com/office/drawing/2014/main" id="{EA23EF97-3CA7-4338-A1C3-AD4D0FC9D2C3}"/>
+                <a16:creationId xmlns:a16="http://schemas.microsoft.com/office/drawing/2014/main" id="{A94F3A01-DB44-4987-979F-CA642180AEBE}"/>
               </a:ext>
             </a:extLst>
           </p:cNvPr>
@@ -23289,7 +23289,7 @@
           <p:cNvPr id="7" name="">
             <a:extLst xmlns:a="http://schemas.openxmlformats.org/drawingml/2006/main">
               <a:ext uri="{FF2B5EF4-FFF2-40B4-BE49-F238E27FC236}">
-                <a16:creationId xmlns:a16="http://schemas.microsoft.com/office/drawing/2014/main" id="{9BB71A82-6B03-4996-8A45-78E5B86B33D4}"/>
+                <a16:creationId xmlns:a16="http://schemas.microsoft.com/office/drawing/2014/main" id="{A7820F56-26BE-45A2-AB54-3477F8C44E45}"/>
               </a:ext>
             </a:extLst>
           </p:cNvPr>
@@ -23445,7 +23445,7 @@
     </p:spTree>
     <p:extLst>
       <p:ext uri="{BB962C8B-B14F-4D97-AF65-F5344CB8AC3E}">
-        <p14:creationId xmlns:p14="http://schemas.microsoft.com/office/powerpoint/2010/main" val="1907148740"/>
+        <p14:creationId xmlns:p14="http://schemas.microsoft.com/office/powerpoint/2010/main" val="2034811243"/>
       </p:ext>
     </p:extLst>
   </p:cSld>
@@ -23476,7 +23476,7 @@
           <p:cNvPr id="16" name="">
             <a:extLst xmlns:a="http://schemas.openxmlformats.org/drawingml/2006/main">
               <a:ext uri="{FF2B5EF4-FFF2-40B4-BE49-F238E27FC236}">
-                <a16:creationId xmlns:a16="http://schemas.microsoft.com/office/drawing/2014/main" id="{1216C218-631E-46E1-B031-B3B24FFD88ED}"/>
+                <a16:creationId xmlns:a16="http://schemas.microsoft.com/office/drawing/2014/main" id="{9F029A4A-AE48-46D5-A73E-3EC10FBE04C0}"/>
               </a:ext>
             </a:extLst>
           </p:cNvPr>
@@ -23634,7 +23634,7 @@
           <p:cNvPr id="2" name="">
             <a:extLst xmlns:a="http://schemas.openxmlformats.org/drawingml/2006/main">
               <a:ext uri="{FF2B5EF4-FFF2-40B4-BE49-F238E27FC236}">
-                <a16:creationId xmlns:a16="http://schemas.microsoft.com/office/drawing/2014/main" id="{62AF2808-D55D-48E7-A019-66165ADE3537}"/>
+                <a16:creationId xmlns:a16="http://schemas.microsoft.com/office/drawing/2014/main" id="{E7580F84-4A8C-476A-B57F-D11DF02CABE0}"/>
               </a:ext>
             </a:extLst>
           </p:cNvPr>
@@ -23792,7 +23792,7 @@
           <p:cNvPr id="3" name="">
             <a:extLst xmlns:a="http://schemas.openxmlformats.org/drawingml/2006/main">
               <a:ext uri="{FF2B5EF4-FFF2-40B4-BE49-F238E27FC236}">
-                <a16:creationId xmlns:a16="http://schemas.microsoft.com/office/drawing/2014/main" id="{EA122DBC-C5DF-4FF0-A184-D8985B955E2E}"/>
+                <a16:creationId xmlns:a16="http://schemas.microsoft.com/office/drawing/2014/main" id="{AFCD3B69-0087-4625-9A2A-E2DCB63D372A}"/>
               </a:ext>
             </a:extLst>
           </p:cNvPr>
@@ -23950,7 +23950,7 @@
           <p:cNvPr id="4" name="">
             <a:extLst xmlns:a="http://schemas.openxmlformats.org/drawingml/2006/main">
               <a:ext uri="{FF2B5EF4-FFF2-40B4-BE49-F238E27FC236}">
-                <a16:creationId xmlns:a16="http://schemas.microsoft.com/office/drawing/2014/main" id="{FDF4C85B-0772-4D7A-9D7C-19F3D5F77E60}"/>
+                <a16:creationId xmlns:a16="http://schemas.microsoft.com/office/drawing/2014/main" id="{53F25CF8-C8AC-4728-8E1F-A25CA3E44CD3}"/>
               </a:ext>
             </a:extLst>
           </p:cNvPr>
@@ -24108,7 +24108,7 @@
           <p:cNvPr id="5" name="">
             <a:extLst xmlns:a="http://schemas.openxmlformats.org/drawingml/2006/main">
               <a:ext uri="{FF2B5EF4-FFF2-40B4-BE49-F238E27FC236}">
-                <a16:creationId xmlns:a16="http://schemas.microsoft.com/office/drawing/2014/main" id="{D8B392E7-C0CB-4005-B790-C227E443B467}"/>
+                <a16:creationId xmlns:a16="http://schemas.microsoft.com/office/drawing/2014/main" id="{9EACDA21-8AAE-435B-B8FE-96F8532999DC}"/>
               </a:ext>
             </a:extLst>
           </p:cNvPr>
@@ -24266,7 +24266,7 @@
           <p:cNvPr id="6" name="">
             <a:extLst xmlns:a="http://schemas.openxmlformats.org/drawingml/2006/main">
               <a:ext uri="{FF2B5EF4-FFF2-40B4-BE49-F238E27FC236}">
-                <a16:creationId xmlns:a16="http://schemas.microsoft.com/office/drawing/2014/main" id="{472FA4A3-E372-45AC-9F1E-565BDD35CE35}"/>
+                <a16:creationId xmlns:a16="http://schemas.microsoft.com/office/drawing/2014/main" id="{81945731-07FD-41FB-9683-8F75D1B1D247}"/>
               </a:ext>
             </a:extLst>
           </p:cNvPr>
@@ -24424,7 +24424,7 @@
           <p:cNvPr id="7" name="">
             <a:extLst xmlns:a="http://schemas.openxmlformats.org/drawingml/2006/main">
               <a:ext uri="{FF2B5EF4-FFF2-40B4-BE49-F238E27FC236}">
-                <a16:creationId xmlns:a16="http://schemas.microsoft.com/office/drawing/2014/main" id="{F0B335B6-A357-4BFC-A1BA-9DFDC29298DA}"/>
+                <a16:creationId xmlns:a16="http://schemas.microsoft.com/office/drawing/2014/main" id="{BF6ADB40-C7A7-4E13-85F1-BF2D1FBB1C80}"/>
               </a:ext>
             </a:extLst>
           </p:cNvPr>
@@ -24605,7 +24605,7 @@
           <p:cNvPr id="8" name="">
             <a:extLst xmlns:a="http://schemas.openxmlformats.org/drawingml/2006/main">
               <a:ext uri="{FF2B5EF4-FFF2-40B4-BE49-F238E27FC236}">
-                <a16:creationId xmlns:a16="http://schemas.microsoft.com/office/drawing/2014/main" id="{EBAF8273-7B9B-41A4-87F2-22463F24F66C}"/>
+                <a16:creationId xmlns:a16="http://schemas.microsoft.com/office/drawing/2014/main" id="{74805DF0-1AFE-4F92-800B-D87C7B1D45D3}"/>
               </a:ext>
             </a:extLst>
           </p:cNvPr>
@@ -24763,7 +24763,7 @@
           <p:cNvPr id="9" name="">
             <a:extLst xmlns:a="http://schemas.openxmlformats.org/drawingml/2006/main">
               <a:ext uri="{FF2B5EF4-FFF2-40B4-BE49-F238E27FC236}">
-                <a16:creationId xmlns:a16="http://schemas.microsoft.com/office/drawing/2014/main" id="{A7C08972-B992-4F8A-9CCE-2BCB740E233C}"/>
+                <a16:creationId xmlns:a16="http://schemas.microsoft.com/office/drawing/2014/main" id="{8F00784A-D2E7-48CF-8347-ED203A330D18}"/>
               </a:ext>
             </a:extLst>
           </p:cNvPr>
@@ -24921,7 +24921,7 @@
           <p:cNvPr id="10" name="">
             <a:extLst xmlns:a="http://schemas.openxmlformats.org/drawingml/2006/main">
               <a:ext uri="{FF2B5EF4-FFF2-40B4-BE49-F238E27FC236}">
-                <a16:creationId xmlns:a16="http://schemas.microsoft.com/office/drawing/2014/main" id="{F9A0D435-2452-463C-B46F-406C0B4C1624}"/>
+                <a16:creationId xmlns:a16="http://schemas.microsoft.com/office/drawing/2014/main" id="{66DCA072-006E-48F1-A4BF-CEAA8FF0D1BE}"/>
               </a:ext>
             </a:extLst>
           </p:cNvPr>
@@ -25102,7 +25102,7 @@
           <p:cNvPr id="11" name="">
             <a:extLst xmlns:a="http://schemas.openxmlformats.org/drawingml/2006/main">
               <a:ext uri="{FF2B5EF4-FFF2-40B4-BE49-F238E27FC236}">
-                <a16:creationId xmlns:a16="http://schemas.microsoft.com/office/drawing/2014/main" id="{A5A64D1C-8510-40F7-A6CE-CAADD7F015F7}"/>
+                <a16:creationId xmlns:a16="http://schemas.microsoft.com/office/drawing/2014/main" id="{CFC4F4F0-4AA2-4E37-B9E1-A530247C8E50}"/>
               </a:ext>
             </a:extLst>
           </p:cNvPr>
@@ -25260,7 +25260,7 @@
           <p:cNvPr id="12" name="">
             <a:extLst xmlns:a="http://schemas.openxmlformats.org/drawingml/2006/main">
               <a:ext uri="{FF2B5EF4-FFF2-40B4-BE49-F238E27FC236}">
-                <a16:creationId xmlns:a16="http://schemas.microsoft.com/office/drawing/2014/main" id="{EA3C90DE-2FAD-4247-982A-649A385B677D}"/>
+                <a16:creationId xmlns:a16="http://schemas.microsoft.com/office/drawing/2014/main" id="{34713A47-5C4A-4418-B312-7F83C22ECB92}"/>
               </a:ext>
             </a:extLst>
           </p:cNvPr>
@@ -25418,7 +25418,7 @@
           <p:cNvPr id="13" name="">
             <a:extLst xmlns:a="http://schemas.openxmlformats.org/drawingml/2006/main">
               <a:ext uri="{FF2B5EF4-FFF2-40B4-BE49-F238E27FC236}">
-                <a16:creationId xmlns:a16="http://schemas.microsoft.com/office/drawing/2014/main" id="{7B576B7C-4656-4183-A668-924119030A34}"/>
+                <a16:creationId xmlns:a16="http://schemas.microsoft.com/office/drawing/2014/main" id="{623DAE4A-2E92-480A-9A18-E5E403AFBA85}"/>
               </a:ext>
             </a:extLst>
           </p:cNvPr>
@@ -25599,7 +25599,7 @@
           <p:cNvPr id="14" name="">
             <a:extLst xmlns:a="http://schemas.openxmlformats.org/drawingml/2006/main">
               <a:ext uri="{FF2B5EF4-FFF2-40B4-BE49-F238E27FC236}">
-                <a16:creationId xmlns:a16="http://schemas.microsoft.com/office/drawing/2014/main" id="{0C48A4D0-9FB3-4172-ADA8-E6ED2CF5E10E}"/>
+                <a16:creationId xmlns:a16="http://schemas.microsoft.com/office/drawing/2014/main" id="{FB0114EA-2EA4-446E-9A65-9F70A5C830C9}"/>
               </a:ext>
             </a:extLst>
           </p:cNvPr>
@@ -25757,7 +25757,7 @@
           <p:cNvPr id="15" name="">
             <a:extLst xmlns:a="http://schemas.openxmlformats.org/drawingml/2006/main">
               <a:ext uri="{FF2B5EF4-FFF2-40B4-BE49-F238E27FC236}">
-                <a16:creationId xmlns:a16="http://schemas.microsoft.com/office/drawing/2014/main" id="{73FA5960-E9D9-4949-87D0-53863D9090CD}"/>
+                <a16:creationId xmlns:a16="http://schemas.microsoft.com/office/drawing/2014/main" id="{4E6273D9-42F3-4607-A76C-0A1D15BF2535}"/>
               </a:ext>
             </a:extLst>
           </p:cNvPr>
@@ -25913,7 +25913,7 @@
     </p:spTree>
     <p:extLst>
       <p:ext uri="{BB962C8B-B14F-4D97-AF65-F5344CB8AC3E}">
-        <p14:creationId xmlns:p14="http://schemas.microsoft.com/office/powerpoint/2010/main" val="315443825"/>
+        <p14:creationId xmlns:p14="http://schemas.microsoft.com/office/powerpoint/2010/main" val="1269127488"/>
       </p:ext>
     </p:extLst>
   </p:cSld>

</xml_diff>